<commit_message>
Align AEGIS intent validation architecture
</commit_message>
<xml_diff>
--- a/docs/scripts/Md_Riaz_Final_Defense_0322310105101024.pptx
+++ b/docs/scripts/Md_Riaz_Final_Defense_0322310105101024.pptx
@@ -11159,7 +11159,7 @@
                         </a:defRPr>
                       </a:pPr>
                       <a:r>
-                        <a:t>Semantic coverage</a:t>
+                        <a:t>Semantic intent validation</a:t>
                       </a:r>
                     </a:p>
                   </a:txBody>
@@ -11240,7 +11240,7 @@
                         </a:defRPr>
                       </a:pPr>
                       <a:r>
-                        <a:t>Vocabulary coverage passes</a:t>
+                        <a:t>Vocabulary intent validation passes</a:t>
                       </a:r>
                     </a:p>
                   </a:txBody>
@@ -11913,7 +11913,7 @@
                         </a:defRPr>
                       </a:pPr>
                       <a:r>
-                        <a:t>Need reports but cannot write SQL</a:t>
+                        <a:t>Need reports but need new report combinations</a:t>
                       </a:r>
                     </a:p>
                   </a:txBody>
@@ -12707,7 +12707,7 @@
                 </a:solidFill>
                 <a:latin typeface="Times New Roman"/>
               </a:rPr>
-              <a:t>• Unsupported combinations are expected to be rejected or clarified, not guessed.</a:t>
+              <a:t>• Unsupported structured intents are expected to be rejected or clarified, not guessed.</a:t>
             </a:r>
           </a:p>
           <a:p>
@@ -12751,7 +12751,7 @@
                 </a:solidFill>
                 <a:latin typeface="Times New Roman"/>
               </a:rPr>
-              <a:t>• Additional commerce datasets would strengthen external validity.</a:t>
+              <a:t>• Vague unsupported language can still be misread during LLM intent extraction.</a:t>
             </a:r>
           </a:p>
           <a:p>
@@ -12773,7 +12773,7 @@
                 </a:solidFill>
                 <a:latin typeface="Times New Roman"/>
               </a:rPr>
-              <a:t>• More admin report oracles can be added over time.</a:t>
+              <a:t>• Additional commerce datasets would strengthen external validity.</a:t>
             </a:r>
           </a:p>
           <a:p>
@@ -17705,7 +17705,7 @@
                         </a:defRPr>
                       </a:pPr>
                       <a:r>
-                        <a:t>Trades open SQL for auditable analytics coverage</a:t>
+                        <a:t>Trades open SQL for auditable analytics intent validation</a:t>
                       </a:r>
                     </a:p>
                   </a:txBody>
@@ -18145,7 +18145,7 @@
                 </a:solidFill>
                 <a:latin typeface="Times New Roman"/>
               </a:rPr>
-              <a:t>• Many systems improve SQL generation accuracy, but still treat SQL text as the model's output.</a:t>
+              <a:t>• Many systems improve SQL generation accuracy, but still let executable SQL be authored by the model.</a:t>
             </a:r>
           </a:p>
           <a:p>
@@ -18876,7 +18876,7 @@
                         </a:defRPr>
                       </a:pPr>
                       <a:r>
-                        <a:t>Use fixed natural-language questions, semantic-coverage tests, and admin-fidelity checks for reproducible evidence.</a:t>
+                        <a:t>Use fixed natural-language questions, semantic-intent validation tests, and admin-fidelity checks for reproducible evidence.</a:t>
                       </a:r>
                     </a:p>
                   </a:txBody>

</xml_diff>

<commit_message>
Polish thesis and defense writing
</commit_message>
<xml_diff>
--- a/docs/scripts/Md_Riaz_Final_Defense_0322310105101024.pptx
+++ b/docs/scripts/Md_Riaz_Final_Defense_0322310105101024.pptx
@@ -4015,20 +4015,14 @@
       </p:pic>
       <p:sp>
         <p:nvSpPr>
-          <p:cNvPr id="15" name="TextBox 14">
-            <a:extLst>
-              <a:ext uri="{FF2B5EF4-FFF2-40B4-BE49-F238E27FC236}">
-                <a16:creationId xmlns:a16="http://schemas.microsoft.com/office/drawing/2014/main" id="{CE67231A-ED4F-8480-A39E-C3D024BD1954}"/>
-              </a:ext>
-            </a:extLst>
-          </p:cNvPr>
+          <p:cNvPr id="9" name="TextBox 8"/>
           <p:cNvSpPr txBox="1"/>
           <p:nvPr/>
         </p:nvSpPr>
         <p:spPr>
           <a:xfrm>
-            <a:off x="3282222" y="6089006"/>
-            <a:ext cx="5627553" cy="646331"/>
+            <a:off x="3282222" y="5413248"/>
+            <a:ext cx="5627553" cy="530352"/>
           </a:xfrm>
           <a:prstGeom prst="rect">
             <a:avLst/>
@@ -4036,41 +4030,35 @@
           <a:noFill/>
         </p:spPr>
         <p:txBody>
-          <a:bodyPr wrap="square" rtlCol="0">
+          <a:bodyPr wrap="square">
             <a:spAutoFit/>
           </a:bodyPr>
           <a:lstStyle/>
           <a:p>
-            <a:pPr algn="ctr"/>
-            <a:r>
-              <a:rPr lang="en-US" sz="2000" b="1" dirty="0">
-                <a:solidFill>
-                  <a:schemeClr val="bg1"/>
-                </a:solidFill>
-                <a:latin typeface="Times New Roman" panose="02020603050405020304" pitchFamily="18" charset="0"/>
-                <a:cs typeface="Times New Roman" panose="02020603050405020304" pitchFamily="18" charset="0"/>
-              </a:rPr>
+            <a:pPr algn="ctr">
+              <a:defRPr sz="1500">
+                <a:latin typeface="Times New Roman"/>
+              </a:defRPr>
+            </a:pPr>
+            <a:r>
               <a:t>Department of Computer Science &amp; Engineering</a:t>
             </a:r>
           </a:p>
           <a:p>
-            <a:pPr algn="ctr"/>
-            <a:r>
-              <a:rPr lang="en-US" sz="1600" dirty="0">
-                <a:solidFill>
-                  <a:schemeClr val="bg1"/>
-                </a:solidFill>
-                <a:latin typeface="Times New Roman" panose="02020603050405020304" pitchFamily="18" charset="0"/>
-                <a:cs typeface="Times New Roman" panose="02020603050405020304" pitchFamily="18" charset="0"/>
-              </a:rPr>
-              <a:t>Pundra University of Science &amp; Technology, Bogura – 5800 </a:t>
-            </a:r>
-          </a:p>
-        </p:txBody>
-      </p:sp>
-      <p:sp>
-        <p:nvSpPr>
-          <p:cNvPr id="16" name="TextBox 15"/>
+            <a:pPr algn="ctr">
+              <a:defRPr sz="1200">
+                <a:latin typeface="Times New Roman"/>
+              </a:defRPr>
+            </a:pPr>
+            <a:r>
+              <a:t>Pundra University of Science &amp; Technology, Bogura - 5800</a:t>
+            </a:r>
+          </a:p>
+        </p:txBody>
+      </p:sp>
+      <p:sp>
+        <p:nvSpPr>
+          <p:cNvPr id="10" name="TextBox 9"/>
           <p:cNvSpPr txBox="1"/>
           <p:nvPr/>
         </p:nvSpPr>
@@ -4103,7 +4091,7 @@
       </p:sp>
       <p:sp>
         <p:nvSpPr>
-          <p:cNvPr id="17" name="TextBox 16"/>
+          <p:cNvPr id="11" name="TextBox 10"/>
           <p:cNvSpPr txBox="1"/>
           <p:nvPr/>
         </p:nvSpPr>
@@ -4136,7 +4124,7 @@
       </p:sp>
       <p:sp>
         <p:nvSpPr>
-          <p:cNvPr id="18" name="TextBox 17"/>
+          <p:cNvPr id="12" name="TextBox 11"/>
           <p:cNvSpPr txBox="1"/>
           <p:nvPr/>
         </p:nvSpPr>
@@ -4237,7 +4225,7 @@
       </p:sp>
       <p:sp>
         <p:nvSpPr>
-          <p:cNvPr id="19" name="TextBox 18"/>
+          <p:cNvPr id="13" name="TextBox 12"/>
           <p:cNvSpPr txBox="1"/>
           <p:nvPr/>
         </p:nvSpPr>
@@ -4270,7 +4258,7 @@
       </p:sp>
       <p:sp>
         <p:nvSpPr>
-          <p:cNvPr id="20" name="TextBox 19"/>
+          <p:cNvPr id="14" name="TextBox 13"/>
           <p:cNvSpPr txBox="1"/>
           <p:nvPr/>
         </p:nvSpPr>
@@ -4779,7 +4767,7 @@
                 </a:solidFill>
                 <a:latin typeface="Times New Roman"/>
               </a:rPr>
-              <a:t>• Business vocabulary:</a:t>
+              <a:t>- Business vocabulary:</a:t>
             </a:r>
             <a:r>
               <a:rPr b="0" i="0" sz="1450">
@@ -4810,7 +4798,7 @@
                 </a:solidFill>
                 <a:latin typeface="Times New Roman"/>
               </a:rPr>
-              <a:t>• Metric definitions:</a:t>
+              <a:t>- Metric definitions:</a:t>
             </a:r>
             <a:r>
               <a:rPr b="0" i="0" sz="1450">
@@ -4841,7 +4829,7 @@
                 </a:solidFill>
                 <a:latin typeface="Times New Roman"/>
               </a:rPr>
-              <a:t>• Dimension definitions:</a:t>
+              <a:t>- Dimension definitions:</a:t>
             </a:r>
             <a:r>
               <a:rPr b="0" i="0" sz="1450">
@@ -4872,7 +4860,7 @@
                 </a:solidFill>
                 <a:latin typeface="Times New Roman"/>
               </a:rPr>
-              <a:t>• Join policy:</a:t>
+              <a:t>- Join policy:</a:t>
             </a:r>
             <a:r>
               <a:rPr b="0" i="0" sz="1450">
@@ -4903,7 +4891,7 @@
                 </a:solidFill>
                 <a:latin typeface="Times New Roman"/>
               </a:rPr>
-              <a:t>• Output contracts:</a:t>
+              <a:t>- Output contracts:</a:t>
             </a:r>
             <a:r>
               <a:rPr b="0" i="0" sz="1450">
@@ -5282,14 +5270,69 @@
       </p:sp>
       <p:sp>
         <p:nvSpPr>
-          <p:cNvPr id="13" name="TextBox 12"/>
+          <p:cNvPr id="13" name="Rounded Rectangle 12"/>
+          <p:cNvSpPr/>
+          <p:nvPr/>
+        </p:nvSpPr>
+        <p:spPr>
+          <a:xfrm>
+            <a:off x="658368" y="1335024"/>
+            <a:ext cx="2880360" cy="566928"/>
+          </a:xfrm>
+          <a:prstGeom prst="roundRect">
+            <a:avLst/>
+          </a:prstGeom>
+          <a:solidFill>
+            <a:srgbClr val="E9F1FA"/>
+          </a:solidFill>
+          <a:ln w="12700">
+            <a:solidFill>
+              <a:srgbClr val="003366"/>
+            </a:solidFill>
+          </a:ln>
+        </p:spPr>
+        <p:style>
+          <a:lnRef idx="1">
+            <a:schemeClr val="accent1"/>
+          </a:lnRef>
+          <a:fillRef idx="3">
+            <a:schemeClr val="accent1"/>
+          </a:fillRef>
+          <a:effectRef idx="2">
+            <a:schemeClr val="accent1"/>
+          </a:effectRef>
+          <a:fontRef idx="minor">
+            <a:schemeClr val="lt1"/>
+          </a:fontRef>
+        </p:style>
+        <p:txBody>
+          <a:bodyPr rtlCol="0" anchor="ctr" wrap="square" lIns="109728" rIns="109728" tIns="54864"/>
+          <a:lstStyle/>
+          <a:p>
+            <a:pPr algn="ctr">
+              <a:defRPr sz="1300" b="1">
+                <a:solidFill>
+                  <a:srgbClr val="003366"/>
+                </a:solidFill>
+                <a:latin typeface="Times New Roman"/>
+              </a:defRPr>
+            </a:pPr>
+            <a:r>
+              <a:t>1. User asks a business question</a:t>
+            </a:r>
+          </a:p>
+        </p:txBody>
+      </p:sp>
+      <p:sp>
+        <p:nvSpPr>
+          <p:cNvPr id="14" name="TextBox 13"/>
           <p:cNvSpPr txBox="1"/>
           <p:nvPr/>
         </p:nvSpPr>
         <p:spPr>
           <a:xfrm>
-            <a:off x="822960" y="1664208"/>
-            <a:ext cx="4937760" cy="4251960"/>
+            <a:off x="822960" y="2048256"/>
+            <a:ext cx="2651760" cy="786384"/>
           </a:xfrm>
           <a:prstGeom prst="rect">
             <a:avLst/>
@@ -5304,7 +5347,7 @@
           <a:p>
             <a:pPr marL="0" indent="0">
               <a:lnSpc>
-                <a:spcPct val="108000"/>
+                <a:spcPct val="100000"/>
               </a:lnSpc>
               <a:spcBef>
                 <a:spcPts val="1200"/>
@@ -5314,19 +5357,141 @@
               </a:spcAft>
             </a:pPr>
             <a:r>
-              <a:rPr b="1" i="0" sz="1450">
+              <a:rPr b="1" i="0" sz="1650">
                 <a:solidFill>
                   <a:srgbClr val="003366"/>
                 </a:solidFill>
                 <a:latin typeface="Times New Roman"/>
               </a:rPr>
-              <a:t>What the LLM may produce:</a:t>
+              <a:t>Example:</a:t>
+            </a:r>
+          </a:p>
+          <a:p>
+            <a:pPr marL="0" indent="0">
+              <a:lnSpc>
+                <a:spcPct val="100000"/>
+              </a:lnSpc>
+              <a:spcBef>
+                <a:spcPts val="1200"/>
+              </a:spcBef>
+              <a:spcAft>
+                <a:spcPts val="500"/>
+              </a:spcAft>
+            </a:pPr>
+            <a:r>
+              <a:rPr b="1" i="0" sz="1650">
+                <a:solidFill>
+                  <a:srgbClr val="003366"/>
+                </a:solidFill>
+                <a:latin typeface="Times New Roman"/>
+              </a:rPr>
+              <a:t>Show order average by status</a:t>
+            </a:r>
+          </a:p>
+        </p:txBody>
+      </p:sp>
+      <p:sp>
+        <p:nvSpPr>
+          <p:cNvPr id="15" name="Rounded Rectangle 14"/>
+          <p:cNvSpPr/>
+          <p:nvPr/>
+        </p:nvSpPr>
+        <p:spPr>
+          <a:xfrm>
+            <a:off x="3886200" y="1335024"/>
+            <a:ext cx="3337560" cy="566928"/>
+          </a:xfrm>
+          <a:prstGeom prst="roundRect">
+            <a:avLst/>
+          </a:prstGeom>
+          <a:solidFill>
+            <a:srgbClr val="E9F1FA"/>
+          </a:solidFill>
+          <a:ln w="12700">
+            <a:solidFill>
+              <a:srgbClr val="003366"/>
+            </a:solidFill>
+          </a:ln>
+        </p:spPr>
+        <p:style>
+          <a:lnRef idx="1">
+            <a:schemeClr val="accent1"/>
+          </a:lnRef>
+          <a:fillRef idx="3">
+            <a:schemeClr val="accent1"/>
+          </a:fillRef>
+          <a:effectRef idx="2">
+            <a:schemeClr val="accent1"/>
+          </a:effectRef>
+          <a:fontRef idx="minor">
+            <a:schemeClr val="lt1"/>
+          </a:fontRef>
+        </p:style>
+        <p:txBody>
+          <a:bodyPr rtlCol="0" anchor="ctr" wrap="square" lIns="109728" rIns="109728" tIns="54864"/>
+          <a:lstStyle/>
+          <a:p>
+            <a:pPr algn="ctr">
+              <a:defRPr sz="1260" b="1">
+                <a:solidFill>
+                  <a:srgbClr val="003366"/>
+                </a:solidFill>
+                <a:latin typeface="Times New Roman"/>
+              </a:defRPr>
+            </a:pPr>
+            <a:r>
+              <a:t>2. Prompt exposes approved vocabulary</a:t>
+            </a:r>
+          </a:p>
+        </p:txBody>
+      </p:sp>
+      <p:sp>
+        <p:nvSpPr>
+          <p:cNvPr id="16" name="TextBox 15"/>
+          <p:cNvSpPr txBox="1"/>
+          <p:nvPr/>
+        </p:nvSpPr>
+        <p:spPr>
+          <a:xfrm>
+            <a:off x="3950208" y="2011680"/>
+            <a:ext cx="3154680" cy="1298448"/>
+          </a:xfrm>
+          <a:prstGeom prst="rect">
+            <a:avLst/>
+          </a:prstGeom>
+          <a:noFill/>
+        </p:spPr>
+        <p:txBody>
+          <a:bodyPr wrap="square" anchor="t" lIns="0" tIns="0" rIns="0">
+            <a:spAutoFit/>
+          </a:bodyPr>
+          <a:lstStyle/>
+          <a:p>
+            <a:pPr marL="0" indent="0">
+              <a:lnSpc>
+                <a:spcPct val="90000"/>
+              </a:lnSpc>
+              <a:spcBef>
+                <a:spcPts val="1200"/>
+              </a:spcBef>
+              <a:spcAft>
+                <a:spcPts val="500"/>
+              </a:spcAft>
+            </a:pPr>
+            <a:r>
+              <a:rPr b="1" i="0" sz="1370">
+                <a:solidFill>
+                  <a:srgbClr val="003366"/>
+                </a:solidFill>
+                <a:latin typeface="Times New Roman"/>
+              </a:rPr>
+              <a:t>Vocabulary excerpt:</a:t>
             </a:r>
           </a:p>
           <a:p>
             <a:pPr marL="256032" indent="-256032">
               <a:lnSpc>
-                <a:spcPct val="108000"/>
+                <a:spcPct val="90000"/>
               </a:lnSpc>
               <a:spcBef>
                 <a:spcPts val="300"/>
@@ -5336,19 +5501,28 @@
               </a:spcAft>
             </a:pPr>
             <a:r>
-              <a:rPr b="0" i="0" sz="1150">
+              <a:rPr b="1" i="0" sz="1070">
+                <a:solidFill>
+                  <a:srgbClr val="003366"/>
+                </a:solidFill>
+                <a:latin typeface="Times New Roman"/>
+              </a:rPr>
+              <a:t>- Metrics:</a:t>
+            </a:r>
+            <a:r>
+              <a:rPr b="0" i="0" sz="1070">
                 <a:solidFill>
                   <a:srgbClr val="333333"/>
                 </a:solidFill>
                 <a:latin typeface="Times New Roman"/>
               </a:rPr>
-              <a:t>• Intent class</a:t>
+              <a:t> revenue, order_count, avg_order_value</a:t>
             </a:r>
           </a:p>
           <a:p>
             <a:pPr marL="256032" indent="-256032">
               <a:lnSpc>
-                <a:spcPct val="108000"/>
+                <a:spcPct val="90000"/>
               </a:lnSpc>
               <a:spcBef>
                 <a:spcPts val="300"/>
@@ -5358,19 +5532,28 @@
               </a:spcAft>
             </a:pPr>
             <a:r>
-              <a:rPr b="0" i="0" sz="1150">
+              <a:rPr b="1" i="0" sz="1070">
+                <a:solidFill>
+                  <a:srgbClr val="003366"/>
+                </a:solidFill>
+                <a:latin typeface="Times New Roman"/>
+              </a:rPr>
+              <a:t>- Dimensions:</a:t>
+            </a:r>
+            <a:r>
+              <a:rPr b="0" i="0" sz="1070">
                 <a:solidFill>
                   <a:srgbClr val="333333"/>
                 </a:solidFill>
                 <a:latin typeface="Times New Roman"/>
               </a:rPr>
-              <a:t>• Metric term</a:t>
+              <a:t> order_status, category, country</a:t>
             </a:r>
           </a:p>
           <a:p>
             <a:pPr marL="256032" indent="-256032">
               <a:lnSpc>
-                <a:spcPct val="108000"/>
+                <a:spcPct val="90000"/>
               </a:lnSpc>
               <a:spcBef>
                 <a:spcPts val="300"/>
@@ -5380,225 +5563,91 @@
               </a:spcAft>
             </a:pPr>
             <a:r>
-              <a:rPr b="0" i="0" sz="1150">
+              <a:rPr b="1" i="0" sz="1070">
+                <a:solidFill>
+                  <a:srgbClr val="003366"/>
+                </a:solidFill>
+                <a:latin typeface="Times New Roman"/>
+              </a:rPr>
+              <a:t>- Output:</a:t>
+            </a:r>
+            <a:r>
+              <a:rPr b="0" i="0" sz="1070">
                 <a:solidFill>
                   <a:srgbClr val="333333"/>
                 </a:solidFill>
                 <a:latin typeface="Times New Roman"/>
               </a:rPr>
-              <a:t>• Dimension term</a:t>
-            </a:r>
-          </a:p>
-          <a:p>
-            <a:pPr marL="256032" indent="-256032">
-              <a:lnSpc>
-                <a:spcPct val="108000"/>
-              </a:lnSpc>
-              <a:spcBef>
-                <a:spcPts val="300"/>
-              </a:spcBef>
-              <a:spcAft>
-                <a:spcPts val="700"/>
-              </a:spcAft>
-            </a:pPr>
-            <a:r>
-              <a:rPr b="0" i="0" sz="1150">
-                <a:solidFill>
-                  <a:srgbClr val="333333"/>
-                </a:solidFill>
-                <a:latin typeface="Times New Roman"/>
-              </a:rPr>
-              <a:t>• Time range</a:t>
-            </a:r>
-          </a:p>
-          <a:p>
-            <a:pPr marL="256032" indent="-256032">
-              <a:lnSpc>
-                <a:spcPct val="108000"/>
-              </a:lnSpc>
-              <a:spcBef>
-                <a:spcPts val="300"/>
-              </a:spcBef>
-              <a:spcAft>
-                <a:spcPts val="700"/>
-              </a:spcAft>
-            </a:pPr>
-            <a:r>
-              <a:rPr b="0" i="0" sz="1150">
-                <a:solidFill>
-                  <a:srgbClr val="333333"/>
-                </a:solidFill>
-                <a:latin typeface="Times New Roman"/>
-              </a:rPr>
-              <a:t>• Filter terms</a:t>
-            </a:r>
-          </a:p>
-          <a:p>
-            <a:pPr marL="256032" indent="-256032">
-              <a:lnSpc>
-                <a:spcPct val="108000"/>
-              </a:lnSpc>
-              <a:spcBef>
-                <a:spcPts val="300"/>
-              </a:spcBef>
-              <a:spcAft>
-                <a:spcPts val="700"/>
-              </a:spcAft>
-            </a:pPr>
-            <a:r>
-              <a:rPr b="0" i="0" sz="1150">
-                <a:solidFill>
-                  <a:srgbClr val="333333"/>
-                </a:solidFill>
-                <a:latin typeface="Times New Roman"/>
-              </a:rPr>
-              <a:t>• Requested output shape</a:t>
-            </a:r>
-          </a:p>
-          <a:p>
-            <a:pPr marL="0" indent="0">
-              <a:lnSpc>
-                <a:spcPct val="108000"/>
-              </a:lnSpc>
-              <a:spcBef>
-                <a:spcPts val="1200"/>
-              </a:spcBef>
-              <a:spcAft>
-                <a:spcPts val="500"/>
-              </a:spcAft>
-            </a:pPr>
-            <a:r>
-              <a:rPr b="1" i="0" sz="1450">
-                <a:solidFill>
-                  <a:srgbClr val="003366"/>
-                </a:solidFill>
-                <a:latin typeface="Times New Roman"/>
-              </a:rPr>
-              <a:t>What the LLM may not produce:</a:t>
-            </a:r>
-          </a:p>
-          <a:p>
-            <a:pPr marL="256032" indent="-256032">
-              <a:lnSpc>
-                <a:spcPct val="108000"/>
-              </a:lnSpc>
-              <a:spcBef>
-                <a:spcPts val="300"/>
-              </a:spcBef>
-              <a:spcAft>
-                <a:spcPts val="700"/>
-              </a:spcAft>
-            </a:pPr>
-            <a:r>
-              <a:rPr b="0" i="0" sz="1150">
-                <a:solidFill>
-                  <a:srgbClr val="333333"/>
-                </a:solidFill>
-                <a:latin typeface="Times New Roman"/>
-              </a:rPr>
-              <a:t>• Raw SQL</a:t>
-            </a:r>
-          </a:p>
-          <a:p>
-            <a:pPr marL="256032" indent="-256032">
-              <a:lnSpc>
-                <a:spcPct val="108000"/>
-              </a:lnSpc>
-              <a:spcBef>
-                <a:spcPts val="300"/>
-              </a:spcBef>
-              <a:spcAft>
-                <a:spcPts val="700"/>
-              </a:spcAft>
-            </a:pPr>
-            <a:r>
-              <a:rPr b="0" i="0" sz="1150">
-                <a:solidFill>
-                  <a:srgbClr val="333333"/>
-                </a:solidFill>
-                <a:latin typeface="Times New Roman"/>
-              </a:rPr>
-              <a:t>• Table names as executable authority</a:t>
-            </a:r>
-          </a:p>
-          <a:p>
-            <a:pPr marL="256032" indent="-256032">
-              <a:lnSpc>
-                <a:spcPct val="108000"/>
-              </a:lnSpc>
-              <a:spcBef>
-                <a:spcPts val="300"/>
-              </a:spcBef>
-              <a:spcAft>
-                <a:spcPts val="700"/>
-              </a:spcAft>
-            </a:pPr>
-            <a:r>
-              <a:rPr b="0" i="0" sz="1150">
-                <a:solidFill>
-                  <a:srgbClr val="333333"/>
-                </a:solidFill>
-                <a:latin typeface="Times New Roman"/>
-              </a:rPr>
-              <a:t>• Join paths</a:t>
-            </a:r>
-          </a:p>
-          <a:p>
-            <a:pPr marL="256032" indent="-256032">
-              <a:lnSpc>
-                <a:spcPct val="108000"/>
-              </a:lnSpc>
-              <a:spcBef>
-                <a:spcPts val="300"/>
-              </a:spcBef>
-              <a:spcAft>
-                <a:spcPts val="700"/>
-              </a:spcAft>
-            </a:pPr>
-            <a:r>
-              <a:rPr b="0" i="0" sz="1150">
-                <a:solidFill>
-                  <a:srgbClr val="333333"/>
-                </a:solidFill>
-                <a:latin typeface="Times New Roman"/>
-              </a:rPr>
-              <a:t>• Write statements</a:t>
-            </a:r>
-          </a:p>
-          <a:p>
-            <a:pPr marL="256032" indent="-256032">
-              <a:lnSpc>
-                <a:spcPct val="108000"/>
-              </a:lnSpc>
-              <a:spcBef>
-                <a:spcPts val="300"/>
-              </a:spcBef>
-              <a:spcAft>
-                <a:spcPts val="700"/>
-              </a:spcAft>
-            </a:pPr>
-            <a:r>
-              <a:rPr b="0" i="0" sz="1150">
-                <a:solidFill>
-                  <a:srgbClr val="333333"/>
-                </a:solidFill>
-                <a:latin typeface="Times New Roman"/>
-              </a:rPr>
-              <a:t>• Arbitrary expressions</a:t>
-            </a:r>
-          </a:p>
-        </p:txBody>
-      </p:sp>
-      <p:sp>
-        <p:nvSpPr>
-          <p:cNvPr id="14" name="Rectangle 13"/>
+              <a:t> kpi, table, matrix, chart</a:t>
+            </a:r>
+          </a:p>
+        </p:txBody>
+      </p:sp>
+      <p:sp>
+        <p:nvSpPr>
+          <p:cNvPr id="17" name="Rounded Rectangle 16"/>
           <p:cNvSpPr/>
           <p:nvPr/>
         </p:nvSpPr>
         <p:spPr>
           <a:xfrm>
-            <a:off x="6172200" y="1783080"/>
-            <a:ext cx="4480560" cy="2103120"/>
+            <a:off x="7882127" y="1335024"/>
+            <a:ext cx="3200400" cy="566928"/>
+          </a:xfrm>
+          <a:prstGeom prst="roundRect">
+            <a:avLst/>
+          </a:prstGeom>
+          <a:solidFill>
+            <a:srgbClr val="E2F0D9"/>
+          </a:solidFill>
+          <a:ln w="12700">
+            <a:solidFill>
+              <a:srgbClr val="003366"/>
+            </a:solidFill>
+          </a:ln>
+        </p:spPr>
+        <p:style>
+          <a:lnRef idx="1">
+            <a:schemeClr val="accent1"/>
+          </a:lnRef>
+          <a:fillRef idx="3">
+            <a:schemeClr val="accent1"/>
+          </a:fillRef>
+          <a:effectRef idx="2">
+            <a:schemeClr val="accent1"/>
+          </a:effectRef>
+          <a:fontRef idx="minor">
+            <a:schemeClr val="lt1"/>
+          </a:fontRef>
+        </p:style>
+        <p:txBody>
+          <a:bodyPr rtlCol="0" anchor="ctr" wrap="square" lIns="109728" rIns="109728" tIns="54864"/>
+          <a:lstStyle/>
+          <a:p>
+            <a:pPr algn="ctr">
+              <a:defRPr sz="1280" b="1">
+                <a:solidFill>
+                  <a:srgbClr val="003366"/>
+                </a:solidFill>
+                <a:latin typeface="Times New Roman"/>
+              </a:defRPr>
+            </a:pPr>
+            <a:r>
+              <a:t>3. LLM returns typed intent</a:t>
+            </a:r>
+          </a:p>
+        </p:txBody>
+      </p:sp>
+      <p:sp>
+        <p:nvSpPr>
+          <p:cNvPr id="18" name="Rectangle 17"/>
+          <p:cNvSpPr/>
+          <p:nvPr/>
+        </p:nvSpPr>
+        <p:spPr>
+          <a:xfrm>
+            <a:off x="7973568" y="2011680"/>
+            <a:ext cx="2971800" cy="1536192"/>
           </a:xfrm>
           <a:prstGeom prst="rect">
             <a:avLst/>
@@ -5627,14 +5676,14 @@
           </a:fontRef>
         </p:style>
         <p:txBody>
-          <a:bodyPr rtlCol="0" anchor="ctr" wrap="square" lIns="109728" tIns="73152"/>
-          <a:lstStyle/>
-          <a:p>
-            <a:pPr algn="ctr">
+          <a:bodyPr rtlCol="0" anchor="t" wrap="square" lIns="36576" tIns="73152"/>
+          <a:lstStyle/>
+          <a:p>
+            <a:pPr algn="l">
               <a:spcAft>
                 <a:spcPts val="100"/>
               </a:spcAft>
-              <a:defRPr sz="1300">
+              <a:defRPr sz="969">
                 <a:solidFill>
                   <a:srgbClr val="505050"/>
                 </a:solidFill>
@@ -5646,11 +5695,11 @@
             </a:r>
           </a:p>
           <a:p>
-            <a:pPr>
+            <a:pPr algn="l">
               <a:spcAft>
                 <a:spcPts val="100"/>
               </a:spcAft>
-              <a:defRPr sz="1300">
+              <a:defRPr sz="969">
                 <a:solidFill>
                   <a:srgbClr val="505050"/>
                 </a:solidFill>
@@ -5662,11 +5711,11 @@
             </a:r>
           </a:p>
           <a:p>
-            <a:pPr>
+            <a:pPr algn="l">
               <a:spcAft>
                 <a:spcPts val="100"/>
               </a:spcAft>
-              <a:defRPr sz="1300">
+              <a:defRPr sz="969">
                 <a:solidFill>
                   <a:srgbClr val="505050"/>
                 </a:solidFill>
@@ -5678,11 +5727,11 @@
             </a:r>
           </a:p>
           <a:p>
-            <a:pPr>
+            <a:pPr algn="l">
               <a:spcAft>
                 <a:spcPts val="100"/>
               </a:spcAft>
-              <a:defRPr sz="1300">
+              <a:defRPr sz="969">
                 <a:solidFill>
                   <a:srgbClr val="505050"/>
                 </a:solidFill>
@@ -5694,11 +5743,11 @@
             </a:r>
           </a:p>
           <a:p>
-            <a:pPr>
+            <a:pPr algn="l">
               <a:spcAft>
                 <a:spcPts val="100"/>
               </a:spcAft>
-              <a:defRPr sz="1300">
+              <a:defRPr sz="969">
                 <a:solidFill>
                   <a:srgbClr val="505050"/>
                 </a:solidFill>
@@ -5706,15 +5755,15 @@
               </a:defRPr>
             </a:pPr>
             <a:r>
-              <a:t>  "time_range": "all_time",</a:t>
-            </a:r>
-          </a:p>
-          <a:p>
-            <a:pPr>
+              <a:t>  "output_shape": "table"</a:t>
+            </a:r>
+          </a:p>
+          <a:p>
+            <a:pPr algn="l">
               <a:spcAft>
                 <a:spcPts val="100"/>
               </a:spcAft>
-              <a:defRPr sz="1300">
+              <a:defRPr sz="969">
                 <a:solidFill>
                   <a:srgbClr val="505050"/>
                 </a:solidFill>
@@ -5722,138 +5771,345 @@
               </a:defRPr>
             </a:pPr>
             <a:r>
-              <a:t>  "output_shape": "table"</a:t>
-            </a:r>
-          </a:p>
-          <a:p>
-            <a:pPr>
-              <a:spcAft>
-                <a:spcPts val="100"/>
-              </a:spcAft>
-              <a:defRPr sz="1300">
-                <a:solidFill>
-                  <a:srgbClr val="505050"/>
-                </a:solidFill>
-                <a:latin typeface="Consolas"/>
-              </a:defRPr>
-            </a:pPr>
-            <a:r>
               <a:t>}</a:t>
             </a:r>
           </a:p>
         </p:txBody>
       </p:sp>
-      <p:sp>
-        <p:nvSpPr>
-          <p:cNvPr id="15" name="TextBox 14"/>
-          <p:cNvSpPr txBox="1"/>
+      <p:cxnSp>
+        <p:nvCxnSpPr>
+          <p:cNvPr id="19" name="Connector 18"/>
+          <p:cNvCxnSpPr/>
           <p:nvPr/>
-        </p:nvSpPr>
-        <p:spPr>
-          <a:xfrm>
-            <a:off x="6172200" y="4160520"/>
-            <a:ext cx="4937760" cy="1600200"/>
-          </a:xfrm>
-          <a:prstGeom prst="rect">
+        </p:nvCxnSpPr>
+        <p:spPr>
+          <a:xfrm>
+            <a:off x="3538728" y="1618488"/>
+            <a:ext cx="347472" cy="0"/>
+          </a:xfrm>
+          <a:prstGeom prst="line">
             <a:avLst/>
           </a:prstGeom>
-          <a:noFill/>
-        </p:spPr>
-        <p:txBody>
-          <a:bodyPr wrap="square" anchor="t" lIns="0" tIns="0" rIns="0">
-            <a:spAutoFit/>
-          </a:bodyPr>
-          <a:lstStyle/>
-          <a:p>
-            <a:pPr marL="0" indent="0">
-              <a:lnSpc>
-                <a:spcPct val="108000"/>
-              </a:lnSpc>
-              <a:spcBef>
-                <a:spcPts val="1200"/>
-              </a:spcBef>
-              <a:spcAft>
-                <a:spcPts val="500"/>
-              </a:spcAft>
-            </a:pPr>
-            <a:r>
-              <a:rPr b="1" i="0" sz="1600">
-                <a:solidFill>
-                  <a:srgbClr val="003366"/>
-                </a:solidFill>
-                <a:latin typeface="Times New Roman"/>
-              </a:rPr>
-              <a:t>Boundary claim:</a:t>
-            </a:r>
-          </a:p>
-          <a:p>
-            <a:pPr marL="256032" indent="-256032">
-              <a:lnSpc>
-                <a:spcPct val="108000"/>
-              </a:lnSpc>
-              <a:spcBef>
-                <a:spcPts val="300"/>
-              </a:spcBef>
-              <a:spcAft>
-                <a:spcPts val="700"/>
-              </a:spcAft>
-            </a:pPr>
-            <a:r>
-              <a:rPr b="0" i="0" sz="1300">
-                <a:solidFill>
-                  <a:srgbClr val="333333"/>
-                </a:solidFill>
-                <a:latin typeface="Times New Roman"/>
-              </a:rPr>
-              <a:t>• The model output is treated as data.</a:t>
-            </a:r>
-          </a:p>
-          <a:p>
-            <a:pPr marL="256032" indent="-256032">
-              <a:lnSpc>
-                <a:spcPct val="108000"/>
-              </a:lnSpc>
-              <a:spcBef>
-                <a:spcPts val="300"/>
-              </a:spcBef>
-              <a:spcAft>
-                <a:spcPts val="700"/>
-              </a:spcAft>
-            </a:pPr>
-            <a:r>
-              <a:rPr b="0" i="0" sz="1300">
-                <a:solidFill>
-                  <a:srgbClr val="333333"/>
-                </a:solidFill>
-                <a:latin typeface="Times New Roman"/>
-              </a:rPr>
-              <a:t>• The compiler accepts only fields that map to semantic-layer entries.</a:t>
-            </a:r>
-          </a:p>
-          <a:p>
-            <a:pPr marL="256032" indent="-256032">
-              <a:lnSpc>
-                <a:spcPct val="108000"/>
-              </a:lnSpc>
-              <a:spcBef>
-                <a:spcPts val="300"/>
-              </a:spcBef>
-              <a:spcAft>
-                <a:spcPts val="700"/>
-              </a:spcAft>
-            </a:pPr>
-            <a:r>
-              <a:rPr b="0" i="0" sz="1300">
-                <a:solidFill>
-                  <a:srgbClr val="333333"/>
-                </a:solidFill>
-                <a:latin typeface="Times New Roman"/>
-              </a:rPr>
-              <a:t>• If a required mapping is absent, the system returns a controlled refusal or clarification instead of inventing SQL.</a:t>
-            </a:r>
-          </a:p>
-        </p:txBody>
-      </p:sp>
+          <a:ln w="25400">
+            <a:solidFill>
+              <a:srgbClr val="003366"/>
+            </a:solidFill>
+          </a:ln>
+        </p:spPr>
+        <p:style>
+          <a:lnRef idx="2">
+            <a:schemeClr val="accent1"/>
+          </a:lnRef>
+          <a:fillRef idx="0">
+            <a:schemeClr val="accent1"/>
+          </a:fillRef>
+          <a:effectRef idx="1">
+            <a:schemeClr val="accent1"/>
+          </a:effectRef>
+          <a:fontRef idx="minor">
+            <a:schemeClr val="tx1"/>
+          </a:fontRef>
+        </p:style>
+      </p:cxnSp>
+      <p:cxnSp>
+        <p:nvCxnSpPr>
+          <p:cNvPr id="20" name="Connector 19"/>
+          <p:cNvCxnSpPr/>
+          <p:nvPr/>
+        </p:nvCxnSpPr>
+        <p:spPr>
+          <a:xfrm>
+            <a:off x="7223760" y="1618488"/>
+            <a:ext cx="658367" cy="0"/>
+          </a:xfrm>
+          <a:prstGeom prst="line">
+            <a:avLst/>
+          </a:prstGeom>
+          <a:ln w="25400">
+            <a:solidFill>
+              <a:srgbClr val="003366"/>
+            </a:solidFill>
+          </a:ln>
+        </p:spPr>
+        <p:style>
+          <a:lnRef idx="2">
+            <a:schemeClr val="accent1"/>
+          </a:lnRef>
+          <a:fillRef idx="0">
+            <a:schemeClr val="accent1"/>
+          </a:fillRef>
+          <a:effectRef idx="1">
+            <a:schemeClr val="accent1"/>
+          </a:effectRef>
+          <a:fontRef idx="minor">
+            <a:schemeClr val="tx1"/>
+          </a:fontRef>
+        </p:style>
+      </p:cxnSp>
+      <p:graphicFrame>
+        <p:nvGraphicFramePr>
+          <p:cNvPr id="21" name="Table 20"/>
+          <p:cNvGraphicFramePr>
+            <a:graphicFrameLocks noGrp="1"/>
+          </p:cNvGraphicFramePr>
+          <p:nvPr/>
+        </p:nvGraphicFramePr>
+        <p:xfrm>
+          <a:off x="804672" y="4279392"/>
+          <a:ext cx="10286999" cy="1298448"/>
+        </p:xfrm>
+        <a:graphic>
+          <a:graphicData uri="http://schemas.openxmlformats.org/drawingml/2006/table">
+            <a:tbl>
+              <a:tblPr firstRow="1" bandRow="1">
+                <a:tableStyleId>{5C22544A-7EE6-4342-B048-85BDC9FD1C3A}</a:tableStyleId>
+              </a:tblPr>
+              <a:tblGrid>
+                <a:gridCol w="2240280"/>
+                <a:gridCol w="3749039"/>
+                <a:gridCol w="4297680"/>
+              </a:tblGrid>
+              <a:tr h="432816">
+                <a:tc>
+                  <a:txBody>
+                    <a:bodyPr/>
+                    <a:lstStyle/>
+                    <a:p>
+                      <a:pPr algn="ctr">
+                        <a:lnSpc>
+                          <a:spcPct val="100000"/>
+                        </a:lnSpc>
+                        <a:defRPr sz="1150" b="1">
+                          <a:solidFill>
+                            <a:srgbClr val="FFFFFF"/>
+                          </a:solidFill>
+                          <a:latin typeface="Times New Roman"/>
+                        </a:defRPr>
+                      </a:pPr>
+                      <a:r>
+                        <a:t>Stage</a:t>
+                      </a:r>
+                    </a:p>
+                  </a:txBody>
+                  <a:tcPr marL="36576" marR="36576" marT="13716" marB="13716" anchor="ctr">
+                    <a:solidFill>
+                      <a:srgbClr val="003366"/>
+                    </a:solidFill>
+                  </a:tcPr>
+                </a:tc>
+                <a:tc>
+                  <a:txBody>
+                    <a:bodyPr/>
+                    <a:lstStyle/>
+                    <a:p>
+                      <a:pPr algn="ctr">
+                        <a:lnSpc>
+                          <a:spcPct val="100000"/>
+                        </a:lnSpc>
+                        <a:defRPr sz="1150" b="1">
+                          <a:solidFill>
+                            <a:srgbClr val="FFFFFF"/>
+                          </a:solidFill>
+                          <a:latin typeface="Times New Roman"/>
+                        </a:defRPr>
+                      </a:pPr>
+                      <a:r>
+                        <a:t>Allowed</a:t>
+                      </a:r>
+                    </a:p>
+                  </a:txBody>
+                  <a:tcPr marL="36576" marR="36576" marT="13716" marB="13716" anchor="ctr">
+                    <a:solidFill>
+                      <a:srgbClr val="003366"/>
+                    </a:solidFill>
+                  </a:tcPr>
+                </a:tc>
+                <a:tc>
+                  <a:txBody>
+                    <a:bodyPr/>
+                    <a:lstStyle/>
+                    <a:p>
+                      <a:pPr algn="ctr">
+                        <a:lnSpc>
+                          <a:spcPct val="100000"/>
+                        </a:lnSpc>
+                        <a:defRPr sz="1150" b="1">
+                          <a:solidFill>
+                            <a:srgbClr val="FFFFFF"/>
+                          </a:solidFill>
+                          <a:latin typeface="Times New Roman"/>
+                        </a:defRPr>
+                      </a:pPr>
+                      <a:r>
+                        <a:t>Not allowed</a:t>
+                      </a:r>
+                    </a:p>
+                  </a:txBody>
+                  <a:tcPr marL="36576" marR="36576" marT="13716" marB="13716" anchor="ctr">
+                    <a:solidFill>
+                      <a:srgbClr val="003366"/>
+                    </a:solidFill>
+                  </a:tcPr>
+                </a:tc>
+              </a:tr>
+              <a:tr h="432816">
+                <a:tc>
+                  <a:txBody>
+                    <a:bodyPr/>
+                    <a:lstStyle/>
+                    <a:p>
+                      <a:pPr algn="ctr">
+                        <a:lnSpc>
+                          <a:spcPct val="100000"/>
+                        </a:lnSpc>
+                        <a:defRPr sz="1060" b="1">
+                          <a:solidFill>
+                            <a:srgbClr val="333333"/>
+                          </a:solidFill>
+                          <a:latin typeface="Times New Roman"/>
+                        </a:defRPr>
+                      </a:pPr>
+                      <a:r>
+                        <a:t>LLM</a:t>
+                      </a:r>
+                    </a:p>
+                  </a:txBody>
+                  <a:tcPr marL="36576" marR="36576" marT="13716" marB="13716" anchor="ctr"/>
+                </a:tc>
+                <a:tc>
+                  <a:txBody>
+                    <a:bodyPr/>
+                    <a:lstStyle/>
+                    <a:p>
+                      <a:pPr algn="l">
+                        <a:lnSpc>
+                          <a:spcPct val="100000"/>
+                        </a:lnSpc>
+                        <a:defRPr sz="1060" b="0">
+                          <a:solidFill>
+                            <a:srgbClr val="333333"/>
+                          </a:solidFill>
+                          <a:latin typeface="Times New Roman"/>
+                        </a:defRPr>
+                      </a:pPr>
+                      <a:r>
+                        <a:t>Choose approved ids from vocabulary</a:t>
+                      </a:r>
+                    </a:p>
+                  </a:txBody>
+                  <a:tcPr marL="36576" marR="36576" marT="13716" marB="13716" anchor="ctr"/>
+                </a:tc>
+                <a:tc>
+                  <a:txBody>
+                    <a:bodyPr/>
+                    <a:lstStyle/>
+                    <a:p>
+                      <a:pPr algn="l">
+                        <a:lnSpc>
+                          <a:spcPct val="100000"/>
+                        </a:lnSpc>
+                        <a:defRPr sz="1060" b="0">
+                          <a:solidFill>
+                            <a:srgbClr val="333333"/>
+                          </a:solidFill>
+                          <a:latin typeface="Times New Roman"/>
+                        </a:defRPr>
+                      </a:pPr>
+                      <a:r>
+                        <a:t>Raw SQL, joins, table names, writes</a:t>
+                      </a:r>
+                    </a:p>
+                  </a:txBody>
+                  <a:tcPr marL="36576" marR="36576" marT="13716" marB="13716" anchor="ctr"/>
+                </a:tc>
+              </a:tr>
+              <a:tr h="432816">
+                <a:tc>
+                  <a:txBody>
+                    <a:bodyPr/>
+                    <a:lstStyle/>
+                    <a:p>
+                      <a:pPr algn="ctr">
+                        <a:lnSpc>
+                          <a:spcPct val="100000"/>
+                        </a:lnSpc>
+                        <a:defRPr sz="1060" b="1">
+                          <a:solidFill>
+                            <a:srgbClr val="333333"/>
+                          </a:solidFill>
+                          <a:latin typeface="Times New Roman"/>
+                        </a:defRPr>
+                      </a:pPr>
+                      <a:r>
+                        <a:t>AEGIS</a:t>
+                      </a:r>
+                    </a:p>
+                  </a:txBody>
+                  <a:tcPr marL="36576" marR="36576" marT="13716" marB="13716" anchor="ctr">
+                    <a:solidFill>
+                      <a:srgbClr val="F2F4F8"/>
+                    </a:solidFill>
+                  </a:tcPr>
+                </a:tc>
+                <a:tc>
+                  <a:txBody>
+                    <a:bodyPr/>
+                    <a:lstStyle/>
+                    <a:p>
+                      <a:pPr algn="l">
+                        <a:lnSpc>
+                          <a:spcPct val="100000"/>
+                        </a:lnSpc>
+                        <a:defRPr sz="1060" b="0">
+                          <a:solidFill>
+                            <a:srgbClr val="333333"/>
+                          </a:solidFill>
+                          <a:latin typeface="Times New Roman"/>
+                        </a:defRPr>
+                      </a:pPr>
+                      <a:r>
+                        <a:t>Bind ids to semantic definitions</a:t>
+                      </a:r>
+                    </a:p>
+                  </a:txBody>
+                  <a:tcPr marL="36576" marR="36576" marT="13716" marB="13716" anchor="ctr">
+                    <a:solidFill>
+                      <a:srgbClr val="F2F4F8"/>
+                    </a:solidFill>
+                  </a:tcPr>
+                </a:tc>
+                <a:tc>
+                  <a:txBody>
+                    <a:bodyPr/>
+                    <a:lstStyle/>
+                    <a:p>
+                      <a:pPr algn="l">
+                        <a:lnSpc>
+                          <a:spcPct val="100000"/>
+                        </a:lnSpc>
+                        <a:defRPr sz="1060" b="0">
+                          <a:solidFill>
+                            <a:srgbClr val="333333"/>
+                          </a:solidFill>
+                          <a:latin typeface="Times New Roman"/>
+                        </a:defRPr>
+                      </a:pPr>
+                      <a:r>
+                        <a:t>Unknown ids, silent fallback, unsafe execution</a:t>
+                      </a:r>
+                    </a:p>
+                  </a:txBody>
+                  <a:tcPr marL="36576" marR="36576" marT="13716" marB="13716" anchor="ctr">
+                    <a:solidFill>
+                      <a:srgbClr val="F2F4F8"/>
+                    </a:solidFill>
+                  </a:tcPr>
+                </a:tc>
+              </a:tr>
+            </a:tbl>
+          </a:graphicData>
+        </a:graphic>
+      </p:graphicFrame>
     </p:spTree>
   </p:cSld>
   <p:clrMapOvr>
@@ -6092,7 +6348,7 @@
               </a:defRPr>
             </a:pPr>
             <a:r>
-              <a:t>Question-to-SQL Walkthrough</a:t>
+              <a:t>Semantic Mapping Under the Hood</a:t>
             </a:r>
           </a:p>
         </p:txBody>
@@ -6225,8 +6481,8 @@
         </p:nvSpPr>
         <p:spPr>
           <a:xfrm>
-            <a:off x="685800" y="1371600"/>
-            <a:ext cx="2331720" cy="713232"/>
+            <a:off x="749808" y="1353312"/>
+            <a:ext cx="2834640" cy="841248"/>
           </a:xfrm>
           <a:prstGeom prst="roundRect">
             <a:avLst/>
@@ -6259,7 +6515,7 @@
           <a:lstStyle/>
           <a:p>
             <a:pPr algn="ctr">
-              <a:defRPr sz="1300" b="1">
+              <a:defRPr sz="1200" b="1">
                 <a:solidFill>
                   <a:srgbClr val="003366"/>
                 </a:solidFill>
@@ -6267,11 +6523,15 @@
               </a:defRPr>
             </a:pPr>
             <a:r>
-              <a:t>User question</a:t>
+              <a:t>Intent received</a:t>
             </a:r>
             <a:br/>
             <a:r>
-              <a:t>"Show order average by status"</a:t>
+              <a:t>metric_term=avg_order_value</a:t>
+            </a:r>
+            <a:br/>
+            <a:r>
+              <a:t>dimension_term=order_status</a:t>
             </a:r>
           </a:p>
         </p:txBody>
@@ -6284,8 +6544,8 @@
         </p:nvSpPr>
         <p:spPr>
           <a:xfrm>
-            <a:off x="3337560" y="1371600"/>
-            <a:ext cx="2514600" cy="713232"/>
+            <a:off x="4572000" y="1353312"/>
+            <a:ext cx="2834640" cy="841248"/>
           </a:xfrm>
           <a:prstGeom prst="roundRect">
             <a:avLst/>
@@ -6326,15 +6586,11 @@
               </a:defRPr>
             </a:pPr>
             <a:r>
-              <a:t>Intent JSON</a:t>
+              <a:t>Lookup in semantic layer</a:t>
             </a:r>
             <a:br/>
             <a:r>
-              <a:t>metric=avg_order_value</a:t>
-            </a:r>
-            <a:br/>
-            <a:r>
-              <a:t>dimension=order_status</a:t>
+              <a:t>METRICS + DIMENSIONS</a:t>
             </a:r>
           </a:p>
         </p:txBody>
@@ -6347,8 +6603,8 @@
         </p:nvSpPr>
         <p:spPr>
           <a:xfrm>
-            <a:off x="6172200" y="1371600"/>
-            <a:ext cx="2514600" cy="713232"/>
+            <a:off x="8339327" y="1353312"/>
+            <a:ext cx="2331720" cy="841248"/>
           </a:xfrm>
           <a:prstGeom prst="roundRect">
             <a:avLst/>
@@ -6389,84 +6645,29 @@
               </a:defRPr>
             </a:pPr>
             <a:r>
-              <a:t>Semantic mapping</a:t>
+              <a:t>Analysis plan</a:t>
             </a:r>
             <a:br/>
             <a:r>
-              <a:t>metric + dimension + matrix pattern</a:t>
-            </a:r>
-          </a:p>
-        </p:txBody>
-      </p:sp>
-      <p:sp>
-        <p:nvSpPr>
-          <p:cNvPr id="16" name="Rounded Rectangle 15"/>
-          <p:cNvSpPr/>
-          <p:nvPr/>
-        </p:nvSpPr>
-        <p:spPr>
-          <a:xfrm>
-            <a:off x="8979408" y="1371600"/>
-            <a:ext cx="2331720" cy="713232"/>
-          </a:xfrm>
-          <a:prstGeom prst="roundRect">
-            <a:avLst/>
-          </a:prstGeom>
-          <a:solidFill>
-            <a:srgbClr val="E2F0D9"/>
-          </a:solidFill>
-          <a:ln w="12700">
-            <a:solidFill>
-              <a:srgbClr val="003366"/>
-            </a:solidFill>
-          </a:ln>
-        </p:spPr>
-        <p:style>
-          <a:lnRef idx="1">
-            <a:schemeClr val="accent1"/>
-          </a:lnRef>
-          <a:fillRef idx="3">
-            <a:schemeClr val="accent1"/>
-          </a:fillRef>
-          <a:effectRef idx="2">
-            <a:schemeClr val="accent1"/>
-          </a:effectRef>
-          <a:fontRef idx="minor">
-            <a:schemeClr val="lt1"/>
-          </a:fontRef>
-        </p:style>
-        <p:txBody>
-          <a:bodyPr rtlCol="0" anchor="ctr" wrap="square" lIns="109728" rIns="109728" tIns="54864"/>
-          <a:lstStyle/>
-          <a:p>
-            <a:pPr algn="ctr">
-              <a:defRPr sz="1300" b="1">
-                <a:solidFill>
-                  <a:srgbClr val="003366"/>
-                </a:solidFill>
-                <a:latin typeface="Times New Roman"/>
-              </a:defRPr>
-            </a:pPr>
-            <a:r>
-              <a:t>Compiler output</a:t>
+              <a:t>pattern=segment</a:t>
             </a:r>
             <a:br/>
             <a:r>
-              <a:t>safe SELECT only</a:t>
+              <a:t>shape=table</a:t>
             </a:r>
           </a:p>
         </p:txBody>
       </p:sp>
       <p:cxnSp>
         <p:nvCxnSpPr>
-          <p:cNvPr id="17" name="Connector 16"/>
+          <p:cNvPr id="16" name="Connector 15"/>
           <p:cNvCxnSpPr/>
           <p:nvPr/>
         </p:nvCxnSpPr>
         <p:spPr>
           <a:xfrm>
-            <a:off x="3017520" y="1728216"/>
-            <a:ext cx="320040" cy="0"/>
+            <a:off x="3584448" y="1773936"/>
+            <a:ext cx="987552" cy="0"/>
           </a:xfrm>
           <a:prstGeom prst="line">
             <a:avLst/>
@@ -6494,14 +6695,14 @@
       </p:cxnSp>
       <p:cxnSp>
         <p:nvCxnSpPr>
-          <p:cNvPr id="18" name="Connector 17"/>
+          <p:cNvPr id="17" name="Connector 16"/>
           <p:cNvCxnSpPr/>
           <p:nvPr/>
         </p:nvCxnSpPr>
         <p:spPr>
           <a:xfrm>
-            <a:off x="5852160" y="1728216"/>
-            <a:ext cx="320040" cy="0"/>
+            <a:off x="7406640" y="1773936"/>
+            <a:ext cx="932687" cy="0"/>
           </a:xfrm>
           <a:prstGeom prst="line">
             <a:avLst/>
@@ -6527,206 +6728,17 @@
           </a:fontRef>
         </p:style>
       </p:cxnSp>
-      <p:cxnSp>
-        <p:nvCxnSpPr>
-          <p:cNvPr id="19" name="Connector 18"/>
-          <p:cNvCxnSpPr/>
-          <p:nvPr/>
-        </p:nvCxnSpPr>
-        <p:spPr>
-          <a:xfrm>
-            <a:off x="8686800" y="1728216"/>
-            <a:ext cx="292608" cy="0"/>
-          </a:xfrm>
-          <a:prstGeom prst="line">
-            <a:avLst/>
-          </a:prstGeom>
-          <a:ln w="25400">
-            <a:solidFill>
-              <a:srgbClr val="003366"/>
-            </a:solidFill>
-          </a:ln>
-        </p:spPr>
-        <p:style>
-          <a:lnRef idx="2">
-            <a:schemeClr val="accent1"/>
-          </a:lnRef>
-          <a:fillRef idx="0">
-            <a:schemeClr val="accent1"/>
-          </a:fillRef>
-          <a:effectRef idx="1">
-            <a:schemeClr val="accent1"/>
-          </a:effectRef>
-          <a:fontRef idx="minor">
-            <a:schemeClr val="tx1"/>
-          </a:fontRef>
-        </p:style>
-      </p:cxnSp>
-      <p:sp>
-        <p:nvSpPr>
-          <p:cNvPr id="20" name="Rectangle 19"/>
-          <p:cNvSpPr/>
-          <p:nvPr/>
-        </p:nvSpPr>
-        <p:spPr>
-          <a:xfrm>
-            <a:off x="960120" y="2743200"/>
-            <a:ext cx="5074920" cy="2057400"/>
-          </a:xfrm>
-          <a:prstGeom prst="rect">
-            <a:avLst/>
-          </a:prstGeom>
-          <a:solidFill>
-            <a:srgbClr val="F7F7F7"/>
-          </a:solidFill>
-          <a:ln>
-            <a:solidFill>
-              <a:srgbClr val="B7B7B7"/>
-            </a:solidFill>
-          </a:ln>
-        </p:spPr>
-        <p:style>
-          <a:lnRef idx="1">
-            <a:schemeClr val="accent1"/>
-          </a:lnRef>
-          <a:fillRef idx="3">
-            <a:schemeClr val="accent1"/>
-          </a:fillRef>
-          <a:effectRef idx="2">
-            <a:schemeClr val="accent1"/>
-          </a:effectRef>
-          <a:fontRef idx="minor">
-            <a:schemeClr val="lt1"/>
-          </a:fontRef>
-        </p:style>
-        <p:txBody>
-          <a:bodyPr rtlCol="0" anchor="ctr" wrap="square" lIns="109728" tIns="73152"/>
-          <a:lstStyle/>
-          <a:p>
-            <a:pPr algn="ctr">
-              <a:spcAft>
-                <a:spcPts val="100"/>
-              </a:spcAft>
-              <a:defRPr sz="1200">
-                <a:solidFill>
-                  <a:srgbClr val="505050"/>
-                </a:solidFill>
-                <a:latin typeface="Consolas"/>
-              </a:defRPr>
-            </a:pPr>
-            <a:r>
-              <a:t>SELECT status_label,</a:t>
-            </a:r>
-          </a:p>
-          <a:p>
-            <a:pPr>
-              <a:spcAft>
-                <a:spcPts val="100"/>
-              </a:spcAft>
-              <a:defRPr sz="1200">
-                <a:solidFill>
-                  <a:srgbClr val="505050"/>
-                </a:solidFill>
-                <a:latin typeface="Consolas"/>
-              </a:defRPr>
-            </a:pPr>
-            <a:r>
-              <a:t>       COUNT(*) AS order_count,</a:t>
-            </a:r>
-          </a:p>
-          <a:p>
-            <a:pPr>
-              <a:spcAft>
-                <a:spcPts val="100"/>
-              </a:spcAft>
-              <a:defRPr sz="1200">
-                <a:solidFill>
-                  <a:srgbClr val="505050"/>
-                </a:solidFill>
-                <a:latin typeface="Consolas"/>
-              </a:defRPr>
-            </a:pPr>
-            <a:r>
-              <a:t>       SUM(OrderTotal) AS revenue,</a:t>
-            </a:r>
-          </a:p>
-          <a:p>
-            <a:pPr>
-              <a:spcAft>
-                <a:spcPts val="100"/>
-              </a:spcAft>
-              <a:defRPr sz="1200">
-                <a:solidFill>
-                  <a:srgbClr val="505050"/>
-                </a:solidFill>
-                <a:latin typeface="Consolas"/>
-              </a:defRPr>
-            </a:pPr>
-            <a:r>
-              <a:t>       AVG(OrderTotal) AS avg_order_value</a:t>
-            </a:r>
-          </a:p>
-          <a:p>
-            <a:pPr>
-              <a:spcAft>
-                <a:spcPts val="100"/>
-              </a:spcAft>
-              <a:defRPr sz="1200">
-                <a:solidFill>
-                  <a:srgbClr val="505050"/>
-                </a:solidFill>
-                <a:latin typeface="Consolas"/>
-              </a:defRPr>
-            </a:pPr>
-            <a:r>
-              <a:t>FROM approved_order_summary</a:t>
-            </a:r>
-          </a:p>
-          <a:p>
-            <a:pPr>
-              <a:spcAft>
-                <a:spcPts val="100"/>
-              </a:spcAft>
-              <a:defRPr sz="1200">
-                <a:solidFill>
-                  <a:srgbClr val="505050"/>
-                </a:solidFill>
-                <a:latin typeface="Consolas"/>
-              </a:defRPr>
-            </a:pPr>
-            <a:r>
-              <a:t>GROUP BY status_label</a:t>
-            </a:r>
-          </a:p>
-          <a:p>
-            <a:pPr>
-              <a:spcAft>
-                <a:spcPts val="100"/>
-              </a:spcAft>
-              <a:defRPr sz="1200">
-                <a:solidFill>
-                  <a:srgbClr val="505050"/>
-                </a:solidFill>
-                <a:latin typeface="Consolas"/>
-              </a:defRPr>
-            </a:pPr>
-            <a:r>
-              <a:t>ORDER BY revenue DESC;</a:t>
-            </a:r>
-          </a:p>
-        </p:txBody>
-      </p:sp>
       <p:graphicFrame>
         <p:nvGraphicFramePr>
-          <p:cNvPr id="21" name="Table 20"/>
+          <p:cNvPr id="18" name="Table 17"/>
           <p:cNvGraphicFramePr>
             <a:graphicFrameLocks noGrp="1"/>
           </p:cNvGraphicFramePr>
           <p:nvPr/>
         </p:nvGraphicFramePr>
         <p:xfrm>
-          <a:off x="6400800" y="2697480"/>
-          <a:ext cx="4754880" cy="2148840"/>
+          <a:off x="685800" y="2606040"/>
+          <a:ext cx="10835640" cy="2148840"/>
         </p:xfrm>
         <a:graphic>
           <a:graphicData uri="http://schemas.openxmlformats.org/drawingml/2006/table">
@@ -6735,12 +6747,13 @@
                 <a:tableStyleId>{5C22544A-7EE6-4342-B048-85BDC9FD1C3A}</a:tableStyleId>
               </a:tblPr>
               <a:tblGrid>
-                <a:gridCol w="1188720"/>
-                <a:gridCol w="1188720"/>
-                <a:gridCol w="1188720"/>
-                <a:gridCol w="1188720"/>
+                <a:gridCol w="1508760"/>
+                <a:gridCol w="1828800"/>
+                <a:gridCol w="2834640"/>
+                <a:gridCol w="2377440"/>
+                <a:gridCol w="2286000"/>
               </a:tblGrid>
-              <a:tr h="429768">
+              <a:tr h="537210">
                 <a:tc>
                   <a:txBody>
                     <a:bodyPr/>
@@ -6758,11 +6771,11 @@
                         </a:defRPr>
                       </a:pPr>
                       <a:r>
-                        <a:t>Status</a:t>
+                        <a:t>Slot</a:t>
                       </a:r>
                     </a:p>
                   </a:txBody>
-                  <a:tcPr marL="91440" marR="91440" marT="45720" marB="45720" anchor="ctr">
+                  <a:tcPr marL="32004" marR="32004" marT="13716" marB="13716" anchor="ctr">
                     <a:solidFill>
                       <a:srgbClr val="003366"/>
                     </a:solidFill>
@@ -6785,11 +6798,11 @@
                         </a:defRPr>
                       </a:pPr>
                       <a:r>
-                        <a:t>Orders</a:t>
+                        <a:t>Resolved id</a:t>
                       </a:r>
                     </a:p>
                   </a:txBody>
-                  <a:tcPr marL="91440" marR="91440" marT="45720" marB="45720" anchor="ctr">
+                  <a:tcPr marL="32004" marR="32004" marT="13716" marB="13716" anchor="ctr">
                     <a:solidFill>
                       <a:srgbClr val="003366"/>
                     </a:solidFill>
@@ -6812,11 +6825,11 @@
                         </a:defRPr>
                       </a:pPr>
                       <a:r>
-                        <a:t>Revenue</a:t>
+                        <a:t>Business meaning</a:t>
                       </a:r>
                     </a:p>
                   </a:txBody>
-                  <a:tcPr marL="91440" marR="91440" marT="45720" marB="45720" anchor="ctr">
+                  <a:tcPr marL="32004" marR="32004" marT="13716" marB="13716" anchor="ctr">
                     <a:solidFill>
                       <a:srgbClr val="003366"/>
                     </a:solidFill>
@@ -6839,40 +6852,15 @@
                         </a:defRPr>
                       </a:pPr>
                       <a:r>
-                        <a:t>AOV</a:t>
+                        <a:t>SQL expression</a:t>
                       </a:r>
                     </a:p>
                   </a:txBody>
-                  <a:tcPr marL="91440" marR="91440" marT="45720" marB="45720" anchor="ctr">
+                  <a:tcPr marL="32004" marR="32004" marT="13716" marB="13716" anchor="ctr">
                     <a:solidFill>
                       <a:srgbClr val="003366"/>
                     </a:solidFill>
                   </a:tcPr>
-                </a:tc>
-              </a:tr>
-              <a:tr h="429768">
-                <a:tc>
-                  <a:txBody>
-                    <a:bodyPr/>
-                    <a:lstStyle/>
-                    <a:p>
-                      <a:pPr algn="l">
-                        <a:lnSpc>
-                          <a:spcPct val="100000"/>
-                        </a:lnSpc>
-                        <a:defRPr sz="1050" b="0">
-                          <a:solidFill>
-                            <a:srgbClr val="333333"/>
-                          </a:solidFill>
-                          <a:latin typeface="Times New Roman"/>
-                        </a:defRPr>
-                      </a:pPr>
-                      <a:r>
-                        <a:t>Complete</a:t>
-                      </a:r>
-                    </a:p>
-                  </a:txBody>
-                  <a:tcPr marL="91440" marR="91440" marT="45720" marB="45720" anchor="ctr"/>
                 </a:tc>
                 <a:tc>
                   <a:txBody>
@@ -6883,7 +6871,36 @@
                         <a:lnSpc>
                           <a:spcPct val="100000"/>
                         </a:lnSpc>
-                        <a:defRPr sz="1050" b="0">
+                        <a:defRPr sz="1050" b="1">
+                          <a:solidFill>
+                            <a:srgbClr val="FFFFFF"/>
+                          </a:solidFill>
+                          <a:latin typeface="Times New Roman"/>
+                        </a:defRPr>
+                      </a:pPr>
+                      <a:r>
+                        <a:t>Binding</a:t>
+                      </a:r>
+                    </a:p>
+                  </a:txBody>
+                  <a:tcPr marL="32004" marR="32004" marT="13716" marB="13716" anchor="ctr">
+                    <a:solidFill>
+                      <a:srgbClr val="003366"/>
+                    </a:solidFill>
+                  </a:tcPr>
+                </a:tc>
+              </a:tr>
+              <a:tr h="537210">
+                <a:tc>
+                  <a:txBody>
+                    <a:bodyPr/>
+                    <a:lstStyle/>
+                    <a:p>
+                      <a:pPr algn="ctr">
+                        <a:lnSpc>
+                          <a:spcPct val="100000"/>
+                        </a:lnSpc>
+                        <a:defRPr sz="980" b="1">
                           <a:solidFill>
                             <a:srgbClr val="333333"/>
                           </a:solidFill>
@@ -6891,11 +6908,11 @@
                         </a:defRPr>
                       </a:pPr>
                       <a:r>
-                        <a:t>1,846</a:t>
+                        <a:t>Metric</a:t>
                       </a:r>
                     </a:p>
                   </a:txBody>
-                  <a:tcPr marL="91440" marR="91440" marT="45720" marB="45720" anchor="ctr"/>
+                  <a:tcPr marL="32004" marR="32004" marT="13716" marB="13716" anchor="ctr"/>
                 </a:tc>
                 <a:tc>
                   <a:txBody>
@@ -6906,7 +6923,7 @@
                         <a:lnSpc>
                           <a:spcPct val="100000"/>
                         </a:lnSpc>
-                        <a:defRPr sz="1050" b="0">
+                        <a:defRPr sz="980" b="0">
                           <a:solidFill>
                             <a:srgbClr val="333333"/>
                           </a:solidFill>
@@ -6914,12 +6931,83 @@
                         </a:defRPr>
                       </a:pPr>
                       <a:r>
-                        <a:t>Tk ...</a:t>
+                        <a:t>avg_order_value</a:t>
                       </a:r>
                     </a:p>
                   </a:txBody>
-                  <a:tcPr marL="91440" marR="91440" marT="45720" marB="45720" anchor="ctr"/>
+                  <a:tcPr marL="32004" marR="32004" marT="13716" marB="13716" anchor="ctr"/>
                 </a:tc>
+                <a:tc>
+                  <a:txBody>
+                    <a:bodyPr/>
+                    <a:lstStyle/>
+                    <a:p>
+                      <a:pPr algn="l">
+                        <a:lnSpc>
+                          <a:spcPct val="100000"/>
+                        </a:lnSpc>
+                        <a:defRPr sz="980" b="0">
+                          <a:solidFill>
+                            <a:srgbClr val="333333"/>
+                          </a:solidFill>
+                          <a:latin typeface="Times New Roman"/>
+                        </a:defRPr>
+                      </a:pPr>
+                      <a:r>
+                        <a:t>Average revenue per order</a:t>
+                      </a:r>
+                    </a:p>
+                  </a:txBody>
+                  <a:tcPr marL="32004" marR="32004" marT="13716" marB="13716" anchor="ctr"/>
+                </a:tc>
+                <a:tc>
+                  <a:txBody>
+                    <a:bodyPr/>
+                    <a:lstStyle/>
+                    <a:p>
+                      <a:pPr algn="l">
+                        <a:lnSpc>
+                          <a:spcPct val="100000"/>
+                        </a:lnSpc>
+                        <a:defRPr sz="980" b="0">
+                          <a:solidFill>
+                            <a:srgbClr val="333333"/>
+                          </a:solidFill>
+                          <a:latin typeface="Times New Roman"/>
+                        </a:defRPr>
+                      </a:pPr>
+                      <a:r>
+                        <a:t>AVG(COALESCE(o.OrderTotal, 0))</a:t>
+                      </a:r>
+                    </a:p>
+                  </a:txBody>
+                  <a:tcPr marL="32004" marR="32004" marT="13716" marB="13716" anchor="ctr"/>
+                </a:tc>
+                <a:tc>
+                  <a:txBody>
+                    <a:bodyPr/>
+                    <a:lstStyle/>
+                    <a:p>
+                      <a:pPr algn="l">
+                        <a:lnSpc>
+                          <a:spcPct val="100000"/>
+                        </a:lnSpc>
+                        <a:defRPr sz="980" b="0">
+                          <a:solidFill>
+                            <a:srgbClr val="333333"/>
+                          </a:solidFill>
+                          <a:latin typeface="Times New Roman"/>
+                        </a:defRPr>
+                      </a:pPr>
+                      <a:r>
+                        <a:t>Order as o</a:t>
+                      </a:r>
+                    </a:p>
+                  </a:txBody>
+                  <a:tcPr marL="32004" marR="32004" marT="13716" marB="13716" anchor="ctr"/>
+                </a:tc>
+              </a:tr>
+              <a:tr h="537210">
                 <a:tc>
                   <a:txBody>
                     <a:bodyPr/>
@@ -6929,7 +7017,7 @@
                         <a:lnSpc>
                           <a:spcPct val="100000"/>
                         </a:lnSpc>
-                        <a:defRPr sz="1050" b="0">
+                        <a:defRPr sz="980" b="1">
                           <a:solidFill>
                             <a:srgbClr val="333333"/>
                           </a:solidFill>
@@ -6937,36 +7025,11 @@
                         </a:defRPr>
                       </a:pPr>
                       <a:r>
-                        <a:t>Tk ...</a:t>
+                        <a:t>Dimension</a:t>
                       </a:r>
                     </a:p>
                   </a:txBody>
-                  <a:tcPr marL="91440" marR="91440" marT="45720" marB="45720" anchor="ctr"/>
-                </a:tc>
-              </a:tr>
-              <a:tr h="429768">
-                <a:tc>
-                  <a:txBody>
-                    <a:bodyPr/>
-                    <a:lstStyle/>
-                    <a:p>
-                      <a:pPr algn="l">
-                        <a:lnSpc>
-                          <a:spcPct val="100000"/>
-                        </a:lnSpc>
-                        <a:defRPr sz="1050" b="0">
-                          <a:solidFill>
-                            <a:srgbClr val="333333"/>
-                          </a:solidFill>
-                          <a:latin typeface="Times New Roman"/>
-                        </a:defRPr>
-                      </a:pPr>
-                      <a:r>
-                        <a:t>Processing</a:t>
-                      </a:r>
-                    </a:p>
-                  </a:txBody>
-                  <a:tcPr marL="91440" marR="91440" marT="45720" marB="45720" anchor="ctr">
+                  <a:tcPr marL="32004" marR="32004" marT="13716" marB="13716" anchor="ctr">
                     <a:solidFill>
                       <a:srgbClr val="F2F4F8"/>
                     </a:solidFill>
@@ -6981,7 +7044,7 @@
                         <a:lnSpc>
                           <a:spcPct val="100000"/>
                         </a:lnSpc>
-                        <a:defRPr sz="1050" b="0">
+                        <a:defRPr sz="980" b="0">
                           <a:solidFill>
                             <a:srgbClr val="333333"/>
                           </a:solidFill>
@@ -6989,11 +7052,11 @@
                         </a:defRPr>
                       </a:pPr>
                       <a:r>
-                        <a:t>312</a:t>
+                        <a:t>order_status</a:t>
                       </a:r>
                     </a:p>
                   </a:txBody>
-                  <a:tcPr marL="91440" marR="91440" marT="45720" marB="45720" anchor="ctr">
+                  <a:tcPr marL="32004" marR="32004" marT="13716" marB="13716" anchor="ctr">
                     <a:solidFill>
                       <a:srgbClr val="F2F4F8"/>
                     </a:solidFill>
@@ -7004,11 +7067,11 @@
                     <a:bodyPr/>
                     <a:lstStyle/>
                     <a:p>
-                      <a:pPr algn="ctr">
+                      <a:pPr algn="l">
                         <a:lnSpc>
                           <a:spcPct val="100000"/>
                         </a:lnSpc>
-                        <a:defRPr sz="1050" b="0">
+                        <a:defRPr sz="980" b="0">
                           <a:solidFill>
                             <a:srgbClr val="333333"/>
                           </a:solidFill>
@@ -7016,11 +7079,11 @@
                         </a:defRPr>
                       </a:pPr>
                       <a:r>
-                        <a:t>Tk ...</a:t>
+                        <a:t>Readable order status label</a:t>
                       </a:r>
                     </a:p>
                   </a:txBody>
-                  <a:tcPr marL="91440" marR="91440" marT="45720" marB="45720" anchor="ctr">
+                  <a:tcPr marL="32004" marR="32004" marT="13716" marB="13716" anchor="ctr">
                     <a:solidFill>
                       <a:srgbClr val="F2F4F8"/>
                     </a:solidFill>
@@ -7031,11 +7094,11 @@
                     <a:bodyPr/>
                     <a:lstStyle/>
                     <a:p>
-                      <a:pPr algn="ctr">
+                      <a:pPr algn="l">
                         <a:lnSpc>
                           <a:spcPct val="100000"/>
                         </a:lnSpc>
-                        <a:defRPr sz="1050" b="0">
+                        <a:defRPr sz="980" b="0">
                           <a:solidFill>
                             <a:srgbClr val="333333"/>
                           </a:solidFill>
@@ -7043,18 +7106,16 @@
                         </a:defRPr>
                       </a:pPr>
                       <a:r>
-                        <a:t>Tk ...</a:t>
+                        <a:t>CASE o.OrderStatusId ... END</a:t>
                       </a:r>
                     </a:p>
                   </a:txBody>
-                  <a:tcPr marL="91440" marR="91440" marT="45720" marB="45720" anchor="ctr">
+                  <a:tcPr marL="32004" marR="32004" marT="13716" marB="13716" anchor="ctr">
                     <a:solidFill>
                       <a:srgbClr val="F2F4F8"/>
                     </a:solidFill>
                   </a:tcPr>
                 </a:tc>
-              </a:tr>
-              <a:tr h="429768">
                 <a:tc>
                   <a:txBody>
                     <a:bodyPr/>
@@ -7064,7 +7125,7 @@
                         <a:lnSpc>
                           <a:spcPct val="100000"/>
                         </a:lnSpc>
-                        <a:defRPr sz="1050" b="0">
+                        <a:defRPr sz="980" b="0">
                           <a:solidFill>
                             <a:srgbClr val="333333"/>
                           </a:solidFill>
@@ -7072,11 +7133,40 @@
                         </a:defRPr>
                       </a:pPr>
                       <a:r>
-                        <a:t>Pending</a:t>
+                        <a:t>Order as o</a:t>
                       </a:r>
                     </a:p>
                   </a:txBody>
-                  <a:tcPr marL="91440" marR="91440" marT="45720" marB="45720" anchor="ctr"/>
+                  <a:tcPr marL="32004" marR="32004" marT="13716" marB="13716" anchor="ctr">
+                    <a:solidFill>
+                      <a:srgbClr val="F2F4F8"/>
+                    </a:solidFill>
+                  </a:tcPr>
+                </a:tc>
+              </a:tr>
+              <a:tr h="537210">
+                <a:tc>
+                  <a:txBody>
+                    <a:bodyPr/>
+                    <a:lstStyle/>
+                    <a:p>
+                      <a:pPr algn="ctr">
+                        <a:lnSpc>
+                          <a:spcPct val="100000"/>
+                        </a:lnSpc>
+                        <a:defRPr sz="980" b="1">
+                          <a:solidFill>
+                            <a:srgbClr val="333333"/>
+                          </a:solidFill>
+                          <a:latin typeface="Times New Roman"/>
+                        </a:defRPr>
+                      </a:pPr>
+                      <a:r>
+                        <a:t>Rule</a:t>
+                      </a:r>
+                    </a:p>
+                  </a:txBody>
+                  <a:tcPr marL="32004" marR="32004" marT="13716" marB="13716" anchor="ctr"/>
                 </a:tc>
                 <a:tc>
                   <a:txBody>
@@ -7087,7 +7177,7 @@
                         <a:lnSpc>
                           <a:spcPct val="100000"/>
                         </a:lnSpc>
-                        <a:defRPr sz="1050" b="0">
+                        <a:defRPr sz="980" b="0">
                           <a:solidFill>
                             <a:srgbClr val="333333"/>
                           </a:solidFill>
@@ -7095,60 +7185,12 @@
                         </a:defRPr>
                       </a:pPr>
                       <a:r>
-                        <a:t>226</a:t>
+                        <a:t>mandatory</a:t>
                       </a:r>
                     </a:p>
                   </a:txBody>
-                  <a:tcPr marL="91440" marR="91440" marT="45720" marB="45720" anchor="ctr"/>
+                  <a:tcPr marL="32004" marR="32004" marT="13716" marB="13716" anchor="ctr"/>
                 </a:tc>
-                <a:tc>
-                  <a:txBody>
-                    <a:bodyPr/>
-                    <a:lstStyle/>
-                    <a:p>
-                      <a:pPr algn="ctr">
-                        <a:lnSpc>
-                          <a:spcPct val="100000"/>
-                        </a:lnSpc>
-                        <a:defRPr sz="1050" b="0">
-                          <a:solidFill>
-                            <a:srgbClr val="333333"/>
-                          </a:solidFill>
-                          <a:latin typeface="Times New Roman"/>
-                        </a:defRPr>
-                      </a:pPr>
-                      <a:r>
-                        <a:t>Tk ...</a:t>
-                      </a:r>
-                    </a:p>
-                  </a:txBody>
-                  <a:tcPr marL="91440" marR="91440" marT="45720" marB="45720" anchor="ctr"/>
-                </a:tc>
-                <a:tc>
-                  <a:txBody>
-                    <a:bodyPr/>
-                    <a:lstStyle/>
-                    <a:p>
-                      <a:pPr algn="ctr">
-                        <a:lnSpc>
-                          <a:spcPct val="100000"/>
-                        </a:lnSpc>
-                        <a:defRPr sz="1050" b="0">
-                          <a:solidFill>
-                            <a:srgbClr val="333333"/>
-                          </a:solidFill>
-                          <a:latin typeface="Times New Roman"/>
-                        </a:defRPr>
-                      </a:pPr>
-                      <a:r>
-                        <a:t>Tk ...</a:t>
-                      </a:r>
-                    </a:p>
-                  </a:txBody>
-                  <a:tcPr marL="91440" marR="91440" marT="45720" marB="45720" anchor="ctr"/>
-                </a:tc>
-              </a:tr>
-              <a:tr h="429768">
                 <a:tc>
                   <a:txBody>
                     <a:bodyPr/>
@@ -7158,7 +7200,7 @@
                         <a:lnSpc>
                           <a:spcPct val="100000"/>
                         </a:lnSpc>
-                        <a:defRPr sz="1050" b="0">
+                        <a:defRPr sz="980" b="0">
                           <a:solidFill>
                             <a:srgbClr val="333333"/>
                           </a:solidFill>
@@ -7166,26 +7208,22 @@
                         </a:defRPr>
                       </a:pPr>
                       <a:r>
-                        <a:t>Cancelled</a:t>
+                        <a:t>Ignore soft-deleted orders</a:t>
                       </a:r>
                     </a:p>
                   </a:txBody>
-                  <a:tcPr marL="91440" marR="91440" marT="45720" marB="45720" anchor="ctr">
-                    <a:solidFill>
-                      <a:srgbClr val="F2F4F8"/>
-                    </a:solidFill>
-                  </a:tcPr>
+                  <a:tcPr marL="32004" marR="32004" marT="13716" marB="13716" anchor="ctr"/>
                 </a:tc>
                 <a:tc>
                   <a:txBody>
                     <a:bodyPr/>
                     <a:lstStyle/>
                     <a:p>
-                      <a:pPr algn="ctr">
+                      <a:pPr algn="l">
                         <a:lnSpc>
                           <a:spcPct val="100000"/>
                         </a:lnSpc>
-                        <a:defRPr sz="1050" b="0">
+                        <a:defRPr sz="980" b="0">
                           <a:solidFill>
                             <a:srgbClr val="333333"/>
                           </a:solidFill>
@@ -7193,26 +7231,22 @@
                         </a:defRPr>
                       </a:pPr>
                       <a:r>
-                        <a:t>116</a:t>
+                        <a:t>o.Deleted = 0</a:t>
                       </a:r>
                     </a:p>
                   </a:txBody>
-                  <a:tcPr marL="91440" marR="91440" marT="45720" marB="45720" anchor="ctr">
-                    <a:solidFill>
-                      <a:srgbClr val="F2F4F8"/>
-                    </a:solidFill>
-                  </a:tcPr>
+                  <a:tcPr marL="32004" marR="32004" marT="13716" marB="13716" anchor="ctr"/>
                 </a:tc>
                 <a:tc>
                   <a:txBody>
                     <a:bodyPr/>
                     <a:lstStyle/>
                     <a:p>
-                      <a:pPr algn="ctr">
+                      <a:pPr algn="l">
                         <a:lnSpc>
                           <a:spcPct val="100000"/>
                         </a:lnSpc>
-                        <a:defRPr sz="1050" b="0">
+                        <a:defRPr sz="980" b="0">
                           <a:solidFill>
                             <a:srgbClr val="333333"/>
                           </a:solidFill>
@@ -7220,42 +7254,11 @@
                         </a:defRPr>
                       </a:pPr>
                       <a:r>
-                        <a:t>Tk ...</a:t>
+                        <a:t>WHERE</a:t>
                       </a:r>
                     </a:p>
                   </a:txBody>
-                  <a:tcPr marL="91440" marR="91440" marT="45720" marB="45720" anchor="ctr">
-                    <a:solidFill>
-                      <a:srgbClr val="F2F4F8"/>
-                    </a:solidFill>
-                  </a:tcPr>
-                </a:tc>
-                <a:tc>
-                  <a:txBody>
-                    <a:bodyPr/>
-                    <a:lstStyle/>
-                    <a:p>
-                      <a:pPr algn="ctr">
-                        <a:lnSpc>
-                          <a:spcPct val="100000"/>
-                        </a:lnSpc>
-                        <a:defRPr sz="1050" b="0">
-                          <a:solidFill>
-                            <a:srgbClr val="333333"/>
-                          </a:solidFill>
-                          <a:latin typeface="Times New Roman"/>
-                        </a:defRPr>
-                      </a:pPr>
-                      <a:r>
-                        <a:t>Tk ...</a:t>
-                      </a:r>
-                    </a:p>
-                  </a:txBody>
-                  <a:tcPr marL="91440" marR="91440" marT="45720" marB="45720" anchor="ctr">
-                    <a:solidFill>
-                      <a:srgbClr val="F2F4F8"/>
-                    </a:solidFill>
-                  </a:tcPr>
+                  <a:tcPr marL="32004" marR="32004" marT="13716" marB="13716" anchor="ctr"/>
                 </a:tc>
               </a:tr>
             </a:tbl>
@@ -7264,14 +7267,14 @@
       </p:graphicFrame>
       <p:sp>
         <p:nvSpPr>
-          <p:cNvPr id="22" name="TextBox 21"/>
+          <p:cNvPr id="19" name="TextBox 18"/>
           <p:cNvSpPr txBox="1"/>
           <p:nvPr/>
         </p:nvSpPr>
         <p:spPr>
           <a:xfrm>
-            <a:off x="960120" y="5120640"/>
-            <a:ext cx="10149840" cy="594360"/>
+            <a:off x="868680" y="5047488"/>
+            <a:ext cx="10241280" cy="658368"/>
           </a:xfrm>
           <a:prstGeom prst="rect">
             <a:avLst/>
@@ -7296,22 +7299,22 @@
               </a:spcAft>
             </a:pPr>
             <a:r>
-              <a:rPr b="1" i="0" sz="1500">
+              <a:rPr b="1" i="0" sz="1450">
                 <a:solidFill>
                   <a:srgbClr val="003366"/>
                 </a:solidFill>
                 <a:latin typeface="Times New Roman"/>
               </a:rPr>
-              <a:t>Proof point:</a:t>
-            </a:r>
-            <a:r>
-              <a:rPr b="0" i="0" sz="1400">
+              <a:t>Under the hood:</a:t>
+            </a:r>
+            <a:r>
+              <a:rPr b="0" i="0" sz="1350">
                 <a:solidFill>
                   <a:srgbClr val="333333"/>
                 </a:solidFill>
                 <a:latin typeface="Times New Roman"/>
               </a:rPr>
-              <a:t> the SQL is selected and compiled from known metric/dimension definitions; the model never writes the SELECT statement.</a:t>
+              <a:t> metric and dimension are not table names from the LLM. They are ids that bind to administrator-authored semantic objects.</a:t>
             </a:r>
           </a:p>
         </p:txBody>
@@ -7554,7 +7557,7 @@
               </a:defRPr>
             </a:pPr>
             <a:r>
-              <a:t>SQL Compiler and Safety Controls</a:t>
+              <a:t>Template-Based SQL Compilation</a:t>
             </a:r>
           </a:p>
         </p:txBody>
@@ -7679,40 +7682,731 @@
           </a:p>
         </p:txBody>
       </p:sp>
-      <p:pic>
-        <p:nvPicPr>
-          <p:cNvPr id="13" name="Picture 12" descr="figure-07-sql-safety-defense.png"/>
-          <p:cNvPicPr>
-            <a:picLocks noChangeAspect="1"/>
-          </p:cNvPicPr>
+      <p:sp>
+        <p:nvSpPr>
+          <p:cNvPr id="13" name="Rounded Rectangle 12"/>
+          <p:cNvSpPr/>
           <p:nvPr/>
-        </p:nvPicPr>
-        <p:blipFill>
-          <a:blip r:embed="rId3"/>
-          <a:stretch>
-            <a:fillRect/>
-          </a:stretch>
-        </p:blipFill>
-        <p:spPr>
-          <a:xfrm>
-            <a:off x="731520" y="1821942"/>
-            <a:ext cx="5212080" cy="3040380"/>
+        </p:nvSpPr>
+        <p:spPr>
+          <a:xfrm>
+            <a:off x="658368" y="1298448"/>
+            <a:ext cx="3154680" cy="530352"/>
+          </a:xfrm>
+          <a:prstGeom prst="roundRect">
+            <a:avLst/>
+          </a:prstGeom>
+          <a:solidFill>
+            <a:srgbClr val="E9F1FA"/>
+          </a:solidFill>
+          <a:ln w="12700">
+            <a:solidFill>
+              <a:srgbClr val="003366"/>
+            </a:solidFill>
+          </a:ln>
+        </p:spPr>
+        <p:style>
+          <a:lnRef idx="1">
+            <a:schemeClr val="accent1"/>
+          </a:lnRef>
+          <a:fillRef idx="3">
+            <a:schemeClr val="accent1"/>
+          </a:fillRef>
+          <a:effectRef idx="2">
+            <a:schemeClr val="accent1"/>
+          </a:effectRef>
+          <a:fontRef idx="minor">
+            <a:schemeClr val="lt1"/>
+          </a:fontRef>
+        </p:style>
+        <p:txBody>
+          <a:bodyPr rtlCol="0" anchor="ctr" wrap="square" lIns="109728" rIns="109728" tIns="54864"/>
+          <a:lstStyle/>
+          <a:p>
+            <a:pPr algn="ctr">
+              <a:defRPr sz="1300" b="1">
+                <a:solidFill>
+                  <a:srgbClr val="003366"/>
+                </a:solidFill>
+                <a:latin typeface="Times New Roman"/>
+              </a:defRPr>
+            </a:pPr>
+            <a:r>
+              <a:t>Compiler template</a:t>
+            </a:r>
+          </a:p>
+        </p:txBody>
+      </p:sp>
+      <p:sp>
+        <p:nvSpPr>
+          <p:cNvPr id="14" name="Rectangle 13"/>
+          <p:cNvSpPr/>
+          <p:nvPr/>
+        </p:nvSpPr>
+        <p:spPr>
+          <a:xfrm>
+            <a:off x="713232" y="1993392"/>
+            <a:ext cx="4526280" cy="2359152"/>
           </a:xfrm>
           <a:prstGeom prst="rect">
             <a:avLst/>
           </a:prstGeom>
-        </p:spPr>
-      </p:pic>
-      <p:sp>
-        <p:nvSpPr>
-          <p:cNvPr id="14" name="TextBox 13"/>
+          <a:solidFill>
+            <a:srgbClr val="F7F7F7"/>
+          </a:solidFill>
+          <a:ln>
+            <a:solidFill>
+              <a:srgbClr val="B7B7B7"/>
+            </a:solidFill>
+          </a:ln>
+        </p:spPr>
+        <p:style>
+          <a:lnRef idx="1">
+            <a:schemeClr val="accent1"/>
+          </a:lnRef>
+          <a:fillRef idx="3">
+            <a:schemeClr val="accent1"/>
+          </a:fillRef>
+          <a:effectRef idx="2">
+            <a:schemeClr val="accent1"/>
+          </a:effectRef>
+          <a:fontRef idx="minor">
+            <a:schemeClr val="lt1"/>
+          </a:fontRef>
+        </p:style>
+        <p:txBody>
+          <a:bodyPr rtlCol="0" anchor="t" wrap="square" lIns="36576" tIns="73152"/>
+          <a:lstStyle/>
+          <a:p>
+            <a:pPr algn="l">
+              <a:spcAft>
+                <a:spcPts val="100"/>
+              </a:spcAft>
+              <a:defRPr sz="930">
+                <a:solidFill>
+                  <a:srgbClr val="505050"/>
+                </a:solidFill>
+                <a:latin typeface="Consolas"/>
+              </a:defRPr>
+            </a:pPr>
+            <a:r>
+              <a:t>SELECT {dimension_expr} AS label,</a:t>
+            </a:r>
+          </a:p>
+          <a:p>
+            <a:pPr algn="l">
+              <a:spcAft>
+                <a:spcPts val="100"/>
+              </a:spcAft>
+              <a:defRPr sz="930">
+                <a:solidFill>
+                  <a:srgbClr val="505050"/>
+                </a:solidFill>
+                <a:latin typeface="Consolas"/>
+              </a:defRPr>
+            </a:pPr>
+            <a:r>
+              <a:t>       {metric_expr} AS value</a:t>
+            </a:r>
+          </a:p>
+          <a:p>
+            <a:pPr algn="l">
+              <a:spcAft>
+                <a:spcPts val="100"/>
+              </a:spcAft>
+              <a:defRPr sz="930">
+                <a:solidFill>
+                  <a:srgbClr val="505050"/>
+                </a:solidFill>
+                <a:latin typeface="Consolas"/>
+              </a:defRPr>
+            </a:pPr>
+            <a:r>
+              <a:t>FROM {base_table}</a:t>
+            </a:r>
+          </a:p>
+          <a:p>
+            <a:pPr algn="l">
+              <a:spcAft>
+                <a:spcPts val="100"/>
+              </a:spcAft>
+              <a:defRPr sz="930">
+                <a:solidFill>
+                  <a:srgbClr val="505050"/>
+                </a:solidFill>
+                <a:latin typeface="Consolas"/>
+              </a:defRPr>
+            </a:pPr>
+            <a:r>
+              <a:t>{join_clauses}</a:t>
+            </a:r>
+          </a:p>
+          <a:p>
+            <a:pPr algn="l">
+              <a:spcAft>
+                <a:spcPts val="100"/>
+              </a:spcAft>
+              <a:defRPr sz="930">
+                <a:solidFill>
+                  <a:srgbClr val="505050"/>
+                </a:solidFill>
+                <a:latin typeface="Consolas"/>
+              </a:defRPr>
+            </a:pPr>
+            <a:r>
+              <a:t>WHERE {mandatory_predicates}</a:t>
+            </a:r>
+          </a:p>
+          <a:p>
+            <a:pPr algn="l">
+              <a:spcAft>
+                <a:spcPts val="100"/>
+              </a:spcAft>
+              <a:defRPr sz="930">
+                <a:solidFill>
+                  <a:srgbClr val="505050"/>
+                </a:solidFill>
+                <a:latin typeface="Consolas"/>
+              </a:defRPr>
+            </a:pPr>
+            <a:r>
+              <a:t>GROUP BY {dimension_group_expr}</a:t>
+            </a:r>
+          </a:p>
+          <a:p>
+            <a:pPr algn="l">
+              <a:spcAft>
+                <a:spcPts val="100"/>
+              </a:spcAft>
+              <a:defRPr sz="930">
+                <a:solidFill>
+                  <a:srgbClr val="505050"/>
+                </a:solidFill>
+                <a:latin typeface="Consolas"/>
+              </a:defRPr>
+            </a:pPr>
+            <a:r>
+              <a:t>ORDER BY value DESC;</a:t>
+            </a:r>
+          </a:p>
+        </p:txBody>
+      </p:sp>
+      <p:sp>
+        <p:nvSpPr>
+          <p:cNvPr id="15" name="Rounded Rectangle 14"/>
+          <p:cNvSpPr/>
+          <p:nvPr/>
+        </p:nvSpPr>
+        <p:spPr>
+          <a:xfrm>
+            <a:off x="5596128" y="1298448"/>
+            <a:ext cx="2606040" cy="530352"/>
+          </a:xfrm>
+          <a:prstGeom prst="roundRect">
+            <a:avLst/>
+          </a:prstGeom>
+          <a:solidFill>
+            <a:srgbClr val="E2F0D9"/>
+          </a:solidFill>
+          <a:ln w="12700">
+            <a:solidFill>
+              <a:srgbClr val="003366"/>
+            </a:solidFill>
+          </a:ln>
+        </p:spPr>
+        <p:style>
+          <a:lnRef idx="1">
+            <a:schemeClr val="accent1"/>
+          </a:lnRef>
+          <a:fillRef idx="3">
+            <a:schemeClr val="accent1"/>
+          </a:fillRef>
+          <a:effectRef idx="2">
+            <a:schemeClr val="accent1"/>
+          </a:effectRef>
+          <a:fontRef idx="minor">
+            <a:schemeClr val="lt1"/>
+          </a:fontRef>
+        </p:style>
+        <p:txBody>
+          <a:bodyPr rtlCol="0" anchor="ctr" wrap="square" lIns="109728" rIns="109728" tIns="54864"/>
+          <a:lstStyle/>
+          <a:p>
+            <a:pPr algn="ctr">
+              <a:defRPr sz="1300" b="1">
+                <a:solidFill>
+                  <a:srgbClr val="003366"/>
+                </a:solidFill>
+                <a:latin typeface="Times New Roman"/>
+              </a:defRPr>
+            </a:pPr>
+            <a:r>
+              <a:t>Filled from semantic layer</a:t>
+            </a:r>
+          </a:p>
+        </p:txBody>
+      </p:sp>
+      <p:sp>
+        <p:nvSpPr>
+          <p:cNvPr id="16" name="TextBox 15"/>
           <p:cNvSpPr txBox="1"/>
           <p:nvPr/>
         </p:nvSpPr>
         <p:spPr>
           <a:xfrm>
-            <a:off x="6172200" y="1627632"/>
-            <a:ext cx="4983480" cy="4160520"/>
+            <a:off x="5623560" y="1938528"/>
+            <a:ext cx="2697480" cy="1965960"/>
+          </a:xfrm>
+          <a:prstGeom prst="rect">
+            <a:avLst/>
+          </a:prstGeom>
+          <a:noFill/>
+        </p:spPr>
+        <p:txBody>
+          <a:bodyPr wrap="square" anchor="t" lIns="0" tIns="0" rIns="0">
+            <a:spAutoFit/>
+          </a:bodyPr>
+          <a:lstStyle/>
+          <a:p>
+            <a:pPr marL="256032" indent="-256032">
+              <a:lnSpc>
+                <a:spcPct val="92000"/>
+              </a:lnSpc>
+              <a:spcBef>
+                <a:spcPts val="300"/>
+              </a:spcBef>
+              <a:spcAft>
+                <a:spcPts val="700"/>
+              </a:spcAft>
+            </a:pPr>
+            <a:r>
+              <a:rPr b="1" i="0" sz="1120">
+                <a:solidFill>
+                  <a:srgbClr val="003366"/>
+                </a:solidFill>
+                <a:latin typeface="Times New Roman"/>
+              </a:rPr>
+              <a:t>- dimension_expr:</a:t>
+            </a:r>
+            <a:r>
+              <a:rPr b="0" i="0" sz="1120">
+                <a:solidFill>
+                  <a:srgbClr val="333333"/>
+                </a:solidFill>
+                <a:latin typeface="Times New Roman"/>
+              </a:rPr>
+              <a:t> CASE order status mapping</a:t>
+            </a:r>
+          </a:p>
+          <a:p>
+            <a:pPr marL="256032" indent="-256032">
+              <a:lnSpc>
+                <a:spcPct val="92000"/>
+              </a:lnSpc>
+              <a:spcBef>
+                <a:spcPts val="300"/>
+              </a:spcBef>
+              <a:spcAft>
+                <a:spcPts val="700"/>
+              </a:spcAft>
+            </a:pPr>
+            <a:r>
+              <a:rPr b="1" i="0" sz="1120">
+                <a:solidFill>
+                  <a:srgbClr val="003366"/>
+                </a:solidFill>
+                <a:latin typeface="Times New Roman"/>
+              </a:rPr>
+              <a:t>- metric_expr:</a:t>
+            </a:r>
+            <a:r>
+              <a:rPr b="0" i="0" sz="1120">
+                <a:solidFill>
+                  <a:srgbClr val="333333"/>
+                </a:solidFill>
+                <a:latin typeface="Times New Roman"/>
+              </a:rPr>
+              <a:t> AVG(order total)</a:t>
+            </a:r>
+          </a:p>
+          <a:p>
+            <a:pPr marL="256032" indent="-256032">
+              <a:lnSpc>
+                <a:spcPct val="92000"/>
+              </a:lnSpc>
+              <a:spcBef>
+                <a:spcPts val="300"/>
+              </a:spcBef>
+              <a:spcAft>
+                <a:spcPts val="700"/>
+              </a:spcAft>
+            </a:pPr>
+            <a:r>
+              <a:rPr b="1" i="0" sz="1120">
+                <a:solidFill>
+                  <a:srgbClr val="003366"/>
+                </a:solidFill>
+                <a:latin typeface="Times New Roman"/>
+              </a:rPr>
+              <a:t>- base_table:</a:t>
+            </a:r>
+            <a:r>
+              <a:rPr b="0" i="0" sz="1120">
+                <a:solidFill>
+                  <a:srgbClr val="333333"/>
+                </a:solidFill>
+                <a:latin typeface="Times New Roman"/>
+              </a:rPr>
+              <a:t> Order o</a:t>
+            </a:r>
+          </a:p>
+          <a:p>
+            <a:pPr marL="256032" indent="-256032">
+              <a:lnSpc>
+                <a:spcPct val="92000"/>
+              </a:lnSpc>
+              <a:spcBef>
+                <a:spcPts val="300"/>
+              </a:spcBef>
+              <a:spcAft>
+                <a:spcPts val="700"/>
+              </a:spcAft>
+            </a:pPr>
+            <a:r>
+              <a:rPr b="1" i="0" sz="1120">
+                <a:solidFill>
+                  <a:srgbClr val="003366"/>
+                </a:solidFill>
+                <a:latin typeface="Times New Roman"/>
+              </a:rPr>
+              <a:t>- joins:</a:t>
+            </a:r>
+            <a:r>
+              <a:rPr b="0" i="0" sz="1120">
+                <a:solidFill>
+                  <a:srgbClr val="333333"/>
+                </a:solidFill>
+                <a:latin typeface="Times New Roman"/>
+              </a:rPr>
+              <a:t> none required here</a:t>
+            </a:r>
+          </a:p>
+          <a:p>
+            <a:pPr marL="256032" indent="-256032">
+              <a:lnSpc>
+                <a:spcPct val="92000"/>
+              </a:lnSpc>
+              <a:spcBef>
+                <a:spcPts val="300"/>
+              </a:spcBef>
+              <a:spcAft>
+                <a:spcPts val="700"/>
+              </a:spcAft>
+            </a:pPr>
+            <a:r>
+              <a:rPr b="1" i="0" sz="1120">
+                <a:solidFill>
+                  <a:srgbClr val="003366"/>
+                </a:solidFill>
+                <a:latin typeface="Times New Roman"/>
+              </a:rPr>
+              <a:t>- predicates:</a:t>
+            </a:r>
+            <a:r>
+              <a:rPr b="0" i="0" sz="1120">
+                <a:solidFill>
+                  <a:srgbClr val="333333"/>
+                </a:solidFill>
+                <a:latin typeface="Times New Roman"/>
+              </a:rPr>
+              <a:t> o.Deleted = 0</a:t>
+            </a:r>
+          </a:p>
+        </p:txBody>
+      </p:sp>
+      <p:sp>
+        <p:nvSpPr>
+          <p:cNvPr id="17" name="Rounded Rectangle 16"/>
+          <p:cNvSpPr/>
+          <p:nvPr/>
+        </p:nvSpPr>
+        <p:spPr>
+          <a:xfrm>
+            <a:off x="8613648" y="1298448"/>
+            <a:ext cx="2560320" cy="530352"/>
+          </a:xfrm>
+          <a:prstGeom prst="roundRect">
+            <a:avLst/>
+          </a:prstGeom>
+          <a:solidFill>
+            <a:srgbClr val="E9F1FA"/>
+          </a:solidFill>
+          <a:ln w="12700">
+            <a:solidFill>
+              <a:srgbClr val="003366"/>
+            </a:solidFill>
+          </a:ln>
+        </p:spPr>
+        <p:style>
+          <a:lnRef idx="1">
+            <a:schemeClr val="accent1"/>
+          </a:lnRef>
+          <a:fillRef idx="3">
+            <a:schemeClr val="accent1"/>
+          </a:fillRef>
+          <a:effectRef idx="2">
+            <a:schemeClr val="accent1"/>
+          </a:effectRef>
+          <a:fontRef idx="minor">
+            <a:schemeClr val="lt1"/>
+          </a:fontRef>
+        </p:style>
+        <p:txBody>
+          <a:bodyPr rtlCol="0" anchor="ctr" wrap="square" lIns="109728" rIns="109728" tIns="54864"/>
+          <a:lstStyle/>
+          <a:p>
+            <a:pPr algn="ctr">
+              <a:defRPr sz="1300" b="1">
+                <a:solidFill>
+                  <a:srgbClr val="003366"/>
+                </a:solidFill>
+                <a:latin typeface="Times New Roman"/>
+              </a:defRPr>
+            </a:pPr>
+            <a:r>
+              <a:t>Compiled safe SELECT</a:t>
+            </a:r>
+          </a:p>
+        </p:txBody>
+      </p:sp>
+      <p:sp>
+        <p:nvSpPr>
+          <p:cNvPr id="18" name="Rectangle 17"/>
+          <p:cNvSpPr/>
+          <p:nvPr/>
+        </p:nvSpPr>
+        <p:spPr>
+          <a:xfrm>
+            <a:off x="8394192" y="1938528"/>
+            <a:ext cx="2880360" cy="2651760"/>
+          </a:xfrm>
+          <a:prstGeom prst="rect">
+            <a:avLst/>
+          </a:prstGeom>
+          <a:solidFill>
+            <a:srgbClr val="F7F7F7"/>
+          </a:solidFill>
+          <a:ln>
+            <a:solidFill>
+              <a:srgbClr val="B7B7B7"/>
+            </a:solidFill>
+          </a:ln>
+        </p:spPr>
+        <p:style>
+          <a:lnRef idx="1">
+            <a:schemeClr val="accent1"/>
+          </a:lnRef>
+          <a:fillRef idx="3">
+            <a:schemeClr val="accent1"/>
+          </a:fillRef>
+          <a:effectRef idx="2">
+            <a:schemeClr val="accent1"/>
+          </a:effectRef>
+          <a:fontRef idx="minor">
+            <a:schemeClr val="lt1"/>
+          </a:fontRef>
+        </p:style>
+        <p:txBody>
+          <a:bodyPr rtlCol="0" anchor="t" wrap="square" lIns="36576" tIns="73152"/>
+          <a:lstStyle/>
+          <a:p>
+            <a:pPr algn="l">
+              <a:spcAft>
+                <a:spcPts val="100"/>
+              </a:spcAft>
+              <a:defRPr sz="720">
+                <a:solidFill>
+                  <a:srgbClr val="505050"/>
+                </a:solidFill>
+                <a:latin typeface="Consolas"/>
+              </a:defRPr>
+            </a:pPr>
+            <a:r>
+              <a:t>SELECT CASE o.OrderStatusId</a:t>
+            </a:r>
+          </a:p>
+          <a:p>
+            <a:pPr algn="l">
+              <a:spcAft>
+                <a:spcPts val="100"/>
+              </a:spcAft>
+              <a:defRPr sz="720">
+                <a:solidFill>
+                  <a:srgbClr val="505050"/>
+                </a:solidFill>
+                <a:latin typeface="Consolas"/>
+              </a:defRPr>
+            </a:pPr>
+            <a:r>
+              <a:t>       WHEN 10 THEN "Pending"</a:t>
+            </a:r>
+          </a:p>
+          <a:p>
+            <a:pPr algn="l">
+              <a:spcAft>
+                <a:spcPts val="100"/>
+              </a:spcAft>
+              <a:defRPr sz="720">
+                <a:solidFill>
+                  <a:srgbClr val="505050"/>
+                </a:solidFill>
+                <a:latin typeface="Consolas"/>
+              </a:defRPr>
+            </a:pPr>
+            <a:r>
+              <a:t>       WHEN 20 THEN "Processing"</a:t>
+            </a:r>
+          </a:p>
+          <a:p>
+            <a:pPr algn="l">
+              <a:spcAft>
+                <a:spcPts val="100"/>
+              </a:spcAft>
+              <a:defRPr sz="720">
+                <a:solidFill>
+                  <a:srgbClr val="505050"/>
+                </a:solidFill>
+                <a:latin typeface="Consolas"/>
+              </a:defRPr>
+            </a:pPr>
+            <a:r>
+              <a:t>       WHEN 30 THEN "Complete"</a:t>
+            </a:r>
+          </a:p>
+          <a:p>
+            <a:pPr algn="l">
+              <a:spcAft>
+                <a:spcPts val="100"/>
+              </a:spcAft>
+              <a:defRPr sz="720">
+                <a:solidFill>
+                  <a:srgbClr val="505050"/>
+                </a:solidFill>
+                <a:latin typeface="Consolas"/>
+              </a:defRPr>
+            </a:pPr>
+            <a:r>
+              <a:t>       WHEN 40 THEN "Cancelled"</a:t>
+            </a:r>
+          </a:p>
+          <a:p>
+            <a:pPr algn="l">
+              <a:spcAft>
+                <a:spcPts val="100"/>
+              </a:spcAft>
+              <a:defRPr sz="720">
+                <a:solidFill>
+                  <a:srgbClr val="505050"/>
+                </a:solidFill>
+                <a:latin typeface="Consolas"/>
+              </a:defRPr>
+            </a:pPr>
+            <a:r>
+              <a:t>       END AS label,</a:t>
+            </a:r>
+          </a:p>
+          <a:p>
+            <a:pPr algn="l">
+              <a:spcAft>
+                <a:spcPts val="100"/>
+              </a:spcAft>
+              <a:defRPr sz="720">
+                <a:solidFill>
+                  <a:srgbClr val="505050"/>
+                </a:solidFill>
+                <a:latin typeface="Consolas"/>
+              </a:defRPr>
+            </a:pPr>
+            <a:r>
+              <a:t>       AVG(COALESCE(o.OrderTotal, 0)) AS value</a:t>
+            </a:r>
+          </a:p>
+          <a:p>
+            <a:pPr algn="l">
+              <a:spcAft>
+                <a:spcPts val="100"/>
+              </a:spcAft>
+              <a:defRPr sz="720">
+                <a:solidFill>
+                  <a:srgbClr val="505050"/>
+                </a:solidFill>
+                <a:latin typeface="Consolas"/>
+              </a:defRPr>
+            </a:pPr>
+            <a:r>
+              <a:t>FROM `Order` o</a:t>
+            </a:r>
+          </a:p>
+          <a:p>
+            <a:pPr algn="l">
+              <a:spcAft>
+                <a:spcPts val="100"/>
+              </a:spcAft>
+              <a:defRPr sz="720">
+                <a:solidFill>
+                  <a:srgbClr val="505050"/>
+                </a:solidFill>
+                <a:latin typeface="Consolas"/>
+              </a:defRPr>
+            </a:pPr>
+            <a:r>
+              <a:t>WHERE o.Deleted = 0</a:t>
+            </a:r>
+          </a:p>
+          <a:p>
+            <a:pPr algn="l">
+              <a:spcAft>
+                <a:spcPts val="100"/>
+              </a:spcAft>
+              <a:defRPr sz="720">
+                <a:solidFill>
+                  <a:srgbClr val="505050"/>
+                </a:solidFill>
+                <a:latin typeface="Consolas"/>
+              </a:defRPr>
+            </a:pPr>
+            <a:r>
+              <a:t>GROUP BY CASE o.OrderStatusId ... END</a:t>
+            </a:r>
+          </a:p>
+          <a:p>
+            <a:pPr algn="l">
+              <a:spcAft>
+                <a:spcPts val="100"/>
+              </a:spcAft>
+              <a:defRPr sz="720">
+                <a:solidFill>
+                  <a:srgbClr val="505050"/>
+                </a:solidFill>
+                <a:latin typeface="Consolas"/>
+              </a:defRPr>
+            </a:pPr>
+            <a:r>
+              <a:t>ORDER BY value DESC;</a:t>
+            </a:r>
+          </a:p>
+        </p:txBody>
+      </p:sp>
+      <p:sp>
+        <p:nvSpPr>
+          <p:cNvPr id="19" name="TextBox 18"/>
+          <p:cNvSpPr txBox="1"/>
+          <p:nvPr/>
+        </p:nvSpPr>
+        <p:spPr>
+          <a:xfrm>
+            <a:off x="822960" y="5074920"/>
+            <a:ext cx="10378440" cy="658368"/>
           </a:xfrm>
           <a:prstGeom prst="rect">
             <a:avLst/>
@@ -7737,211 +8431,22 @@
               </a:spcAft>
             </a:pPr>
             <a:r>
-              <a:rPr b="1" i="0" sz="1800">
+              <a:rPr b="1" i="0" sz="1430">
                 <a:solidFill>
                   <a:srgbClr val="003366"/>
                 </a:solidFill>
                 <a:latin typeface="Times New Roman"/>
               </a:rPr>
-              <a:t>Compiler responsibilities:</a:t>
-            </a:r>
-          </a:p>
-          <a:p>
-            <a:pPr marL="256032" indent="-256032">
-              <a:lnSpc>
-                <a:spcPct val="108000"/>
-              </a:lnSpc>
-              <a:spcBef>
-                <a:spcPts val="300"/>
-              </a:spcBef>
-              <a:spcAft>
-                <a:spcPts val="700"/>
-              </a:spcAft>
-            </a:pPr>
-            <a:r>
-              <a:rPr b="0" i="0" sz="1500">
+              <a:t>Safety point:</a:t>
+            </a:r>
+            <a:r>
+              <a:rPr b="0" i="0" sz="1330">
                 <a:solidFill>
                   <a:srgbClr val="333333"/>
                 </a:solidFill>
                 <a:latin typeface="Times New Roman"/>
               </a:rPr>
-              <a:t>• Resolve metric and dimension ids from the semantic layer.</a:t>
-            </a:r>
-          </a:p>
-          <a:p>
-            <a:pPr marL="256032" indent="-256032">
-              <a:lnSpc>
-                <a:spcPct val="108000"/>
-              </a:lnSpc>
-              <a:spcBef>
-                <a:spcPts val="300"/>
-              </a:spcBef>
-              <a:spcAft>
-                <a:spcPts val="700"/>
-              </a:spcAft>
-            </a:pPr>
-            <a:r>
-              <a:rPr b="0" i="0" sz="1500">
-                <a:solidFill>
-                  <a:srgbClr val="333333"/>
-                </a:solidFill>
-                <a:latin typeface="Times New Roman"/>
-              </a:rPr>
-              <a:t>• Add only allowed joins and filters.</a:t>
-            </a:r>
-          </a:p>
-          <a:p>
-            <a:pPr marL="256032" indent="-256032">
-              <a:lnSpc>
-                <a:spcPct val="108000"/>
-              </a:lnSpc>
-              <a:spcBef>
-                <a:spcPts val="300"/>
-              </a:spcBef>
-              <a:spcAft>
-                <a:spcPts val="700"/>
-              </a:spcAft>
-            </a:pPr>
-            <a:r>
-              <a:rPr b="0" i="0" sz="1500">
-                <a:solidFill>
-                  <a:srgbClr val="333333"/>
-                </a:solidFill>
-                <a:latin typeface="Times New Roman"/>
-              </a:rPr>
-              <a:t>• Compile read-only SQL for MySQL.</a:t>
-            </a:r>
-          </a:p>
-          <a:p>
-            <a:pPr marL="256032" indent="-256032">
-              <a:lnSpc>
-                <a:spcPct val="108000"/>
-              </a:lnSpc>
-              <a:spcBef>
-                <a:spcPts val="300"/>
-              </a:spcBef>
-              <a:spcAft>
-                <a:spcPts val="700"/>
-              </a:spcAft>
-            </a:pPr>
-            <a:r>
-              <a:rPr b="0" i="0" sz="1500">
-                <a:solidFill>
-                  <a:srgbClr val="333333"/>
-                </a:solidFill>
-                <a:latin typeface="Times New Roman"/>
-              </a:rPr>
-              <a:t>• Validate SQL structure before execution.</a:t>
-            </a:r>
-          </a:p>
-          <a:p>
-            <a:pPr marL="0" indent="0">
-              <a:lnSpc>
-                <a:spcPct val="108000"/>
-              </a:lnSpc>
-              <a:spcBef>
-                <a:spcPts val="1200"/>
-              </a:spcBef>
-              <a:spcAft>
-                <a:spcPts val="500"/>
-              </a:spcAft>
-            </a:pPr>
-            <a:r>
-              <a:rPr b="1" i="0" sz="1800">
-                <a:solidFill>
-                  <a:srgbClr val="003366"/>
-                </a:solidFill>
-                <a:latin typeface="Times New Roman"/>
-              </a:rPr>
-              <a:t>Safety controls:</a:t>
-            </a:r>
-          </a:p>
-          <a:p>
-            <a:pPr marL="256032" indent="-256032">
-              <a:lnSpc>
-                <a:spcPct val="108000"/>
-              </a:lnSpc>
-              <a:spcBef>
-                <a:spcPts val="300"/>
-              </a:spcBef>
-              <a:spcAft>
-                <a:spcPts val="700"/>
-              </a:spcAft>
-            </a:pPr>
-            <a:r>
-              <a:rPr b="0" i="0" sz="1500">
-                <a:solidFill>
-                  <a:srgbClr val="333333"/>
-                </a:solidFill>
-                <a:latin typeface="Times New Roman"/>
-              </a:rPr>
-              <a:t>• No DDL or DML.</a:t>
-            </a:r>
-          </a:p>
-          <a:p>
-            <a:pPr marL="256032" indent="-256032">
-              <a:lnSpc>
-                <a:spcPct val="108000"/>
-              </a:lnSpc>
-              <a:spcBef>
-                <a:spcPts val="300"/>
-              </a:spcBef>
-              <a:spcAft>
-                <a:spcPts val="700"/>
-              </a:spcAft>
-            </a:pPr>
-            <a:r>
-              <a:rPr b="0" i="0" sz="1500">
-                <a:solidFill>
-                  <a:srgbClr val="333333"/>
-                </a:solidFill>
-                <a:latin typeface="Times New Roman"/>
-              </a:rPr>
-              <a:t>• No unapproved tables or columns.</a:t>
-            </a:r>
-          </a:p>
-          <a:p>
-            <a:pPr marL="256032" indent="-256032">
-              <a:lnSpc>
-                <a:spcPct val="108000"/>
-              </a:lnSpc>
-              <a:spcBef>
-                <a:spcPts val="300"/>
-              </a:spcBef>
-              <a:spcAft>
-                <a:spcPts val="700"/>
-              </a:spcAft>
-            </a:pPr>
-            <a:r>
-              <a:rPr b="0" i="0" sz="1500">
-                <a:solidFill>
-                  <a:srgbClr val="333333"/>
-                </a:solidFill>
-                <a:latin typeface="Times New Roman"/>
-              </a:rPr>
-              <a:t>• No silent fallback to a plausible metric.</a:t>
-            </a:r>
-          </a:p>
-          <a:p>
-            <a:pPr marL="256032" indent="-256032">
-              <a:lnSpc>
-                <a:spcPct val="108000"/>
-              </a:lnSpc>
-              <a:spcBef>
-                <a:spcPts val="300"/>
-              </a:spcBef>
-              <a:spcAft>
-                <a:spcPts val="700"/>
-              </a:spcAft>
-            </a:pPr>
-            <a:r>
-              <a:rPr b="0" i="0" sz="1500">
-                <a:solidFill>
-                  <a:srgbClr val="333333"/>
-                </a:solidFill>
-                <a:latin typeface="Times New Roman"/>
-              </a:rPr>
-              <a:t>• Refuse or clarify unsupported requests.</a:t>
+              <a:t> the template controls SQL structure; the semantic layer supplies approved identifiers and expressions; user text is never inserted into the query.</a:t>
             </a:r>
           </a:p>
         </p:txBody>
@@ -8395,7 +8900,7 @@
                 </a:solidFill>
                 <a:latin typeface="Times New Roman"/>
               </a:rPr>
-              <a:t>• KPI:</a:t>
+              <a:t>- KPI:</a:t>
             </a:r>
             <a:r>
               <a:rPr b="0" i="0" sz="1420">
@@ -8426,7 +8931,7 @@
                 </a:solidFill>
                 <a:latin typeface="Times New Roman"/>
               </a:rPr>
-              <a:t>• Table:</a:t>
+              <a:t>- Table:</a:t>
             </a:r>
             <a:r>
               <a:rPr b="0" i="0" sz="1420">
@@ -8457,7 +8962,7 @@
                 </a:solidFill>
                 <a:latin typeface="Times New Roman"/>
               </a:rPr>
-              <a:t>• Matrix:</a:t>
+              <a:t>- Matrix:</a:t>
             </a:r>
             <a:r>
               <a:rPr b="0" i="0" sz="1420">
@@ -8488,7 +8993,7 @@
                 </a:solidFill>
                 <a:latin typeface="Times New Roman"/>
               </a:rPr>
-              <a:t>• Chart-ready output:</a:t>
+              <a:t>- Chart-ready output:</a:t>
             </a:r>
             <a:r>
               <a:rPr b="0" i="0" sz="1420">
@@ -8949,7 +9454,7 @@
                 </a:solidFill>
                 <a:latin typeface="Times New Roman"/>
               </a:rPr>
-              <a:t>• FastAPI backend for NL analytics requests.</a:t>
+              <a:t>- FastAPI backend for NL analytics requests.</a:t>
             </a:r>
           </a:p>
           <a:p>
@@ -8971,7 +9476,7 @@
                 </a:solidFill>
                 <a:latin typeface="Times New Roman"/>
               </a:rPr>
-              <a:t>• MySQL seeded with nopCommerce-style [7] commerce data.</a:t>
+              <a:t>- MySQL seeded with nopCommerce-style [7] commerce data.</a:t>
             </a:r>
           </a:p>
           <a:p>
@@ -8993,7 +9498,7 @@
                 </a:solidFill>
                 <a:latin typeface="Times New Roman"/>
               </a:rPr>
-              <a:t>• OpenAI-compatible LLM API for intent extraction.</a:t>
+              <a:t>- OpenAI-compatible LLM API for intent extraction.</a:t>
             </a:r>
           </a:p>
           <a:p>
@@ -9015,7 +9520,7 @@
                 </a:solidFill>
                 <a:latin typeface="Times New Roman"/>
               </a:rPr>
-              <a:t>• Semantic-layer files define metrics, dimensions, filters, and output shapes.</a:t>
+              <a:t>- Semantic-layer files define metrics, dimensions, filters, and output shapes.</a:t>
             </a:r>
           </a:p>
           <a:p>
@@ -9037,7 +9542,7 @@
                 </a:solidFill>
                 <a:latin typeface="Times New Roman"/>
               </a:rPr>
-              <a:t>• Frontend shows answer output plus AEGIS stage evidence.</a:t>
+              <a:t>- Frontend shows answer output plus AEGIS stage evidence.</a:t>
             </a:r>
           </a:p>
         </p:txBody>
@@ -9643,7 +10148,7 @@
                 </a:solidFill>
                 <a:latin typeface="Times New Roman"/>
               </a:rPr>
-              <a:t>• Docker build includes app, database seed scripts, and smoke checks.</a:t>
+              <a:t>- Docker build includes app, database seed scripts, and smoke checks.</a:t>
             </a:r>
           </a:p>
           <a:p>
@@ -9665,7 +10170,7 @@
                 </a:solidFill>
                 <a:latin typeface="Times New Roman"/>
               </a:rPr>
-              <a:t>• Local health test verified database connection and seeded counts.</a:t>
+              <a:t>- Local health test verified database connection and seeded counts.</a:t>
             </a:r>
           </a:p>
         </p:txBody>
@@ -11398,7 +11903,7 @@
                 </a:solidFill>
                 <a:latin typeface="Times New Roman"/>
               </a:rPr>
-              <a:t> the benchmark checks validate the implemented nopCommerce [7] semantic-layer scope.</a:t>
+              <a:t> the benchmark checks validate the implemented nopCommerce [7] semantic layer scope.</a:t>
             </a:r>
           </a:p>
         </p:txBody>
@@ -12663,7 +13168,7 @@
                 </a:solidFill>
                 <a:latin typeface="Times New Roman"/>
               </a:rPr>
-              <a:t>• The prototype is implemented and tested for nopCommerce-style [7] analytics on MySQL.</a:t>
+              <a:t>- The prototype is implemented and tested for nopCommerce-style [7] analytics on MySQL.</a:t>
             </a:r>
           </a:p>
           <a:p>
@@ -12685,7 +13190,7 @@
                 </a:solidFill>
                 <a:latin typeface="Times New Roman"/>
               </a:rPr>
-              <a:t>• The semantic layer is intentionally finite and deployment-specific.</a:t>
+              <a:t>- The semantic layer is intentionally finite and deployment-specific.</a:t>
             </a:r>
           </a:p>
           <a:p>
@@ -12707,7 +13212,7 @@
                 </a:solidFill>
                 <a:latin typeface="Times New Roman"/>
               </a:rPr>
-              <a:t>• Unsupported structured intents are expected to be rejected or clarified, not guessed.</a:t>
+              <a:t>- Unsupported structured intents are expected to be rejected or clarified, not guessed.</a:t>
             </a:r>
           </a:p>
           <a:p>
@@ -12751,7 +13256,7 @@
                 </a:solidFill>
                 <a:latin typeface="Times New Roman"/>
               </a:rPr>
-              <a:t>• Vague unsupported language can still be misread during LLM intent extraction.</a:t>
+              <a:t>- Vague unsupported language can still be misread during LLM intent extraction.</a:t>
             </a:r>
           </a:p>
           <a:p>
@@ -12773,7 +13278,7 @@
                 </a:solidFill>
                 <a:latin typeface="Times New Roman"/>
               </a:rPr>
-              <a:t>• Additional commerce datasets would strengthen external validity.</a:t>
+              <a:t>- Additional commerce datasets would strengthen external validity.</a:t>
             </a:r>
           </a:p>
           <a:p>
@@ -12795,7 +13300,7 @@
                 </a:solidFill>
                 <a:latin typeface="Times New Roman"/>
               </a:rPr>
-              <a:t>• Other SQL dialects require compiler extensions.</a:t>
+              <a:t>- Other SQL dialects require compiler extensions.</a:t>
             </a:r>
           </a:p>
           <a:p>
@@ -12839,7 +13344,7 @@
                 </a:solidFill>
                 <a:latin typeface="Times New Roman"/>
               </a:rPr>
-              <a:t>• Multi-turn conversation is outside this thesis because the work evaluates single-request natural-language analytics.</a:t>
+              <a:t>- Multi-turn conversation is outside this thesis because the work evaluates single-request natural-language analytics.</a:t>
             </a:r>
           </a:p>
         </p:txBody>
@@ -13269,7 +13774,7 @@
                 </a:solidFill>
                 <a:latin typeface="Times New Roman"/>
               </a:rPr>
-              <a:t>• AEGIS keeps the LLM useful for language understanding while removing SQL-authoring authority from the model.</a:t>
+              <a:t>- AEGIS keeps the LLM useful for language understanding while removing SQL-authoring authority from the model.</a:t>
             </a:r>
           </a:p>
           <a:p>
@@ -13291,7 +13796,7 @@
                 </a:solidFill>
                 <a:latin typeface="Times New Roman"/>
               </a:rPr>
-              <a:t>• The semantic layer makes analytics definitions explicit, auditable, and reusable for a target system.</a:t>
+              <a:t>- The semantic layer makes analytics definitions explicit, auditable, and reusable for a target system.</a:t>
             </a:r>
           </a:p>
           <a:p>
@@ -13313,7 +13818,7 @@
                 </a:solidFill>
                 <a:latin typeface="Times New Roman"/>
               </a:rPr>
-              <a:t>• The compiler produces read-only SQL from approved definitions and blocks unsupported execution paths.</a:t>
+              <a:t>- The compiler produces read-only SQL from approved definitions and blocks unsupported execution paths.</a:t>
             </a:r>
           </a:p>
           <a:p>
@@ -13335,7 +13840,7 @@
                 </a:solidFill>
                 <a:latin typeface="Times New Roman"/>
               </a:rPr>
-              <a:t>• The nopCommerce [7] prototype, static datasets, and admin-fidelity checks show that the approach can be implemented and evaluated practically.</a:t>
+              <a:t>- The nopCommerce [7] prototype, static datasets, and admin-fidelity checks show that the approach can be implemented and evaluated practically.</a:t>
             </a:r>
           </a:p>
           <a:p>
@@ -13379,7 +13884,7 @@
                 </a:solidFill>
                 <a:latin typeface="Times New Roman"/>
               </a:rPr>
-              <a:t>• A constraint-based architecture for safe LLM-assisted natural language analytics.</a:t>
+              <a:t>- A constraint-based architecture for safe LLM-assisted natural language analytics.</a:t>
             </a:r>
           </a:p>
         </p:txBody>
@@ -14437,7 +14942,7 @@
                 </a:solidFill>
                 <a:latin typeface="Times New Roman"/>
               </a:rPr>
-              <a:t>• Evaluate AEGIS on another e-commerce system by replacing only the semantic layer.</a:t>
+              <a:t>- Evaluate AEGIS on another e-commerce system by replacing only the semantic layer.</a:t>
             </a:r>
           </a:p>
           <a:p>
@@ -14459,7 +14964,7 @@
                 </a:solidFill>
                 <a:latin typeface="Times New Roman"/>
               </a:rPr>
-              <a:t>• Add more oracle reports from real admin and business workflows.</a:t>
+              <a:t>- Add more oracle reports from real admin and business workflows.</a:t>
             </a:r>
           </a:p>
           <a:p>
@@ -14481,7 +14986,7 @@
                 </a:solidFill>
                 <a:latin typeface="Times New Roman"/>
               </a:rPr>
-              <a:t>• Extend compiler modules for PostgreSQL and SQL Server.</a:t>
+              <a:t>- Extend compiler modules for PostgreSQL and SQL Server.</a:t>
             </a:r>
           </a:p>
           <a:p>
@@ -14503,7 +15008,7 @@
                 </a:solidFill>
                 <a:latin typeface="Times New Roman"/>
               </a:rPr>
-              <a:t>• Improve clarification behavior for ambiguous but answerable user questions.</a:t>
+              <a:t>- Improve clarification behavior for ambiguous but answerable user questions.</a:t>
             </a:r>
           </a:p>
           <a:p>
@@ -14525,7 +15030,7 @@
                 </a:solidFill>
                 <a:latin typeface="Times New Roman"/>
               </a:rPr>
-              <a:t>• Add richer chart recommendation while keeping SQL generation deterministic.</a:t>
+              <a:t>- Add richer chart recommendation while keeping SQL generation deterministic.</a:t>
             </a:r>
           </a:p>
         </p:txBody>
@@ -15886,7 +16391,7 @@
                 </a:solidFill>
                 <a:latin typeface="Times New Roman"/>
               </a:rPr>
-              <a:t>• E-commerce systems store rich operational data, but built-in dashboards answer only a fixed set of questions.</a:t>
+              <a:t>- E-commerce systems store rich operational data, but built-in dashboards answer only a fixed set of questions.</a:t>
             </a:r>
           </a:p>
           <a:p>
@@ -15908,7 +16413,7 @@
                 </a:solidFill>
                 <a:latin typeface="Times New Roman"/>
               </a:rPr>
-              <a:t>• When users need new analytical combinations, the request usually depends on a developer or BI person to translate it into report logic.</a:t>
+              <a:t>- When users need new analytical combinations, the request usually depends on a developer or BI person to translate it into report logic.</a:t>
             </a:r>
           </a:p>
           <a:p>
@@ -15930,7 +16435,7 @@
                 </a:solidFill>
                 <a:latin typeface="Times New Roman"/>
               </a:rPr>
-              <a:t>• Natural language analytics can reduce that delay for managers, sales teams, and administrators.</a:t>
+              <a:t>- Natural language analytics can reduce that delay for managers, sales teams, and administrators.</a:t>
             </a:r>
           </a:p>
           <a:p>
@@ -15974,7 +16479,7 @@
                 </a:solidFill>
                 <a:latin typeface="Times New Roman"/>
               </a:rPr>
-              <a:t>• Direct LLM-to-SQL systems are flexible, but the model writes executable database code.</a:t>
+              <a:t>- Direct LLM-to-SQL systems are flexible, but the model writes executable database code.</a:t>
             </a:r>
           </a:p>
           <a:p>
@@ -15996,7 +16501,7 @@
                 </a:solidFill>
                 <a:latin typeface="Times New Roman"/>
               </a:rPr>
-              <a:t>• A safe analytics system should understand the question without giving the model authority to create arbitrary SQL.</a:t>
+              <a:t>- A safe analytics system should understand the question without giving the model authority to create arbitrary SQL.</a:t>
             </a:r>
           </a:p>
           <a:p>
@@ -16040,7 +16545,7 @@
                 </a:solidFill>
                 <a:latin typeface="Times New Roman"/>
               </a:rPr>
-              <a:t>• Use the LLM for intent extraction only.</a:t>
+              <a:t>- Use the LLM for intent extraction only.</a:t>
             </a:r>
           </a:p>
           <a:p>
@@ -16062,7 +16567,7 @@
                 </a:solidFill>
                 <a:latin typeface="Times New Roman"/>
               </a:rPr>
-              <a:t>• Use deterministic semantic mapping and SQL compilation for execution.</a:t>
+              <a:t>- Use deterministic semantic mapping and SQL compilation for execution.</a:t>
             </a:r>
           </a:p>
         </p:txBody>
@@ -18145,7 +18650,7 @@
                 </a:solidFill>
                 <a:latin typeface="Times New Roman"/>
               </a:rPr>
-              <a:t>• Many systems improve SQL generation accuracy, but still let executable SQL be authored by the model.</a:t>
+              <a:t>- Many systems improve SQL generation accuracy, but still let executable SQL be authored by the model.</a:t>
             </a:r>
           </a:p>
           <a:p>
@@ -18167,7 +18672,7 @@
                 </a:solidFill>
                 <a:latin typeface="Times New Roman"/>
               </a:rPr>
-              <a:t>• Visualization systems help users express analysis, but do not fully address database execution safety.</a:t>
+              <a:t>- Visualization systems help users express analysis, but do not fully address database execution safety.</a:t>
             </a:r>
           </a:p>
           <a:p>
@@ -18189,7 +18694,7 @@
                 </a:solidFill>
                 <a:latin typeface="Times New Roman"/>
               </a:rPr>
-              <a:t>• Parser and repair methods can reject invalid syntax, yet syntactically valid SQL can still be unsafe or semantically wrong.</a:t>
+              <a:t>- Parser and repair methods can reject invalid syntax, yet syntactically valid SQL can still be unsafe or semantically wrong.</a:t>
             </a:r>
           </a:p>
           <a:p>
@@ -18233,7 +18738,7 @@
                 </a:solidFill>
                 <a:latin typeface="Times New Roman"/>
               </a:rPr>
-              <a:t>• A practical architecture is needed where natural language is accepted, but executable SQL is produced only from an explicit semantic layer and deterministic compiler.</a:t>
+              <a:t>- A practical architecture is needed where natural language is accepted, but executable SQL is produced only from an explicit semantic layer and deterministic compiler.</a:t>
             </a:r>
           </a:p>
         </p:txBody>
@@ -19270,169 +19775,14 @@
         </p:blipFill>
         <p:spPr>
           <a:xfrm>
-            <a:off x="731520" y="2221992"/>
-            <a:ext cx="5120640" cy="2560320"/>
+            <a:off x="1577340" y="1572768"/>
+            <a:ext cx="9052560" cy="4526280"/>
           </a:xfrm>
           <a:prstGeom prst="rect">
             <a:avLst/>
           </a:prstGeom>
         </p:spPr>
       </p:pic>
-      <p:sp>
-        <p:nvSpPr>
-          <p:cNvPr id="14" name="TextBox 13"/>
-          <p:cNvSpPr txBox="1"/>
-          <p:nvPr/>
-        </p:nvSpPr>
-        <p:spPr>
-          <a:xfrm>
-            <a:off x="6080760" y="1719072"/>
-            <a:ext cx="5120640" cy="3840480"/>
-          </a:xfrm>
-          <a:prstGeom prst="rect">
-            <a:avLst/>
-          </a:prstGeom>
-          <a:noFill/>
-        </p:spPr>
-        <p:txBody>
-          <a:bodyPr wrap="square" anchor="t" lIns="0" tIns="0" rIns="0">
-            <a:spAutoFit/>
-          </a:bodyPr>
-          <a:lstStyle/>
-          <a:p>
-            <a:pPr marL="0" indent="0">
-              <a:lnSpc>
-                <a:spcPct val="108000"/>
-              </a:lnSpc>
-              <a:spcBef>
-                <a:spcPts val="1200"/>
-              </a:spcBef>
-              <a:spcAft>
-                <a:spcPts val="500"/>
-              </a:spcAft>
-            </a:pPr>
-            <a:r>
-              <a:rPr b="1" i="0" sz="1900">
-                <a:solidFill>
-                  <a:srgbClr val="003366"/>
-                </a:solidFill>
-                <a:latin typeface="Times New Roman"/>
-              </a:rPr>
-              <a:t>Design Science Research Process:</a:t>
-            </a:r>
-          </a:p>
-          <a:p>
-            <a:pPr marL="256032" indent="-256032">
-              <a:lnSpc>
-                <a:spcPct val="108000"/>
-              </a:lnSpc>
-              <a:spcBef>
-                <a:spcPts val="300"/>
-              </a:spcBef>
-              <a:spcAft>
-                <a:spcPts val="700"/>
-              </a:spcAft>
-            </a:pPr>
-            <a:r>
-              <a:rPr b="0" i="0" sz="1600">
-                <a:solidFill>
-                  <a:srgbClr val="333333"/>
-                </a:solidFill>
-                <a:latin typeface="Times New Roman"/>
-              </a:rPr>
-              <a:t>• Identify the unsafe execution problem in LLM-assisted database analytics.</a:t>
-            </a:r>
-          </a:p>
-          <a:p>
-            <a:pPr marL="256032" indent="-256032">
-              <a:lnSpc>
-                <a:spcPct val="108000"/>
-              </a:lnSpc>
-              <a:spcBef>
-                <a:spcPts val="300"/>
-              </a:spcBef>
-              <a:spcAft>
-                <a:spcPts val="700"/>
-              </a:spcAft>
-            </a:pPr>
-            <a:r>
-              <a:rPr b="0" i="0" sz="1600">
-                <a:solidFill>
-                  <a:srgbClr val="333333"/>
-                </a:solidFill>
-                <a:latin typeface="Times New Roman"/>
-              </a:rPr>
-              <a:t>• Design a constraint-based architecture where SQL is compiled from explicit definitions.</a:t>
-            </a:r>
-          </a:p>
-          <a:p>
-            <a:pPr marL="256032" indent="-256032">
-              <a:lnSpc>
-                <a:spcPct val="108000"/>
-              </a:lnSpc>
-              <a:spcBef>
-                <a:spcPts val="300"/>
-              </a:spcBef>
-              <a:spcAft>
-                <a:spcPts val="700"/>
-              </a:spcAft>
-            </a:pPr>
-            <a:r>
-              <a:rPr b="0" i="0" sz="1600">
-                <a:solidFill>
-                  <a:srgbClr val="333333"/>
-                </a:solidFill>
-                <a:latin typeface="Times New Roman"/>
-              </a:rPr>
-              <a:t>• Implement the prototype for nopCommerce [7] on MySQL.</a:t>
-            </a:r>
-          </a:p>
-          <a:p>
-            <a:pPr marL="256032" indent="-256032">
-              <a:lnSpc>
-                <a:spcPct val="108000"/>
-              </a:lnSpc>
-              <a:spcBef>
-                <a:spcPts val="300"/>
-              </a:spcBef>
-              <a:spcAft>
-                <a:spcPts val="700"/>
-              </a:spcAft>
-            </a:pPr>
-            <a:r>
-              <a:rPr b="0" i="0" sz="1600">
-                <a:solidFill>
-                  <a:srgbClr val="333333"/>
-                </a:solidFill>
-                <a:latin typeface="Times New Roman"/>
-              </a:rPr>
-              <a:t>• Evaluate with static datasets and executable oracle checks.</a:t>
-            </a:r>
-          </a:p>
-          <a:p>
-            <a:pPr marL="256032" indent="-256032">
-              <a:lnSpc>
-                <a:spcPct val="108000"/>
-              </a:lnSpc>
-              <a:spcBef>
-                <a:spcPts val="300"/>
-              </a:spcBef>
-              <a:spcAft>
-                <a:spcPts val="700"/>
-              </a:spcAft>
-            </a:pPr>
-            <a:r>
-              <a:rPr b="0" i="0" sz="1600">
-                <a:solidFill>
-                  <a:srgbClr val="333333"/>
-                </a:solidFill>
-                <a:latin typeface="Times New Roman"/>
-              </a:rPr>
-              <a:t>• Refine implementation gaps before freezing thesis claims.</a:t>
-            </a:r>
-          </a:p>
-        </p:txBody>
-      </p:sp>
     </p:spTree>
   </p:cSld>
   <p:clrMapOvr>
@@ -19812,68 +20162,14 @@
         </p:blipFill>
         <p:spPr>
           <a:xfrm>
-            <a:off x="2514600" y="1143000"/>
-            <a:ext cx="7132320" cy="4160520"/>
+            <a:off x="1758261" y="1097280"/>
+            <a:ext cx="8699862" cy="5074920"/>
           </a:xfrm>
           <a:prstGeom prst="rect">
             <a:avLst/>
           </a:prstGeom>
         </p:spPr>
       </p:pic>
-      <p:sp>
-        <p:nvSpPr>
-          <p:cNvPr id="14" name="TextBox 13"/>
-          <p:cNvSpPr txBox="1"/>
-          <p:nvPr/>
-        </p:nvSpPr>
-        <p:spPr>
-          <a:xfrm>
-            <a:off x="1005840" y="5440680"/>
-            <a:ext cx="10149840" cy="548640"/>
-          </a:xfrm>
-          <a:prstGeom prst="rect">
-            <a:avLst/>
-          </a:prstGeom>
-          <a:noFill/>
-        </p:spPr>
-        <p:txBody>
-          <a:bodyPr wrap="square" anchor="t" lIns="0" tIns="0" rIns="0">
-            <a:spAutoFit/>
-          </a:bodyPr>
-          <a:lstStyle/>
-          <a:p>
-            <a:pPr marL="0" indent="0">
-              <a:lnSpc>
-                <a:spcPct val="108000"/>
-              </a:lnSpc>
-              <a:spcBef>
-                <a:spcPts val="1200"/>
-              </a:spcBef>
-              <a:spcAft>
-                <a:spcPts val="500"/>
-              </a:spcAft>
-            </a:pPr>
-            <a:r>
-              <a:rPr b="1" i="0" sz="1550">
-                <a:solidFill>
-                  <a:srgbClr val="003366"/>
-                </a:solidFill>
-                <a:latin typeface="Times New Roman"/>
-              </a:rPr>
-              <a:t>Main architectural rule:</a:t>
-            </a:r>
-            <a:r>
-              <a:rPr b="0" i="0" sz="1450">
-                <a:solidFill>
-                  <a:srgbClr val="333333"/>
-                </a:solidFill>
-                <a:latin typeface="Times New Roman"/>
-              </a:rPr>
-              <a:t> the LLM extracts intent only; approved code maps that intent to semantic definitions and compiled SQL.</a:t>
-            </a:r>
-          </a:p>
-        </p:txBody>
-      </p:sp>
     </p:spTree>
   </p:cSld>
   <p:clrMapOvr>

</xml_diff>